<commit_message>
docs: Add panel documentation, calibration reports, and session transcripts
Includes:
- Panel output documents (SOCIAL-I, MEMORY-I, MULTI-I, etc.)
- Calibration session transcripts and reports
- Architecture and design documentation
- Sprint completion reports and decision logs

Co-Authored-By: Claude Opus 4.5 <noreply@anthropic.com>
</commit_message>
<xml_diff>
--- a/docs/03_Implicit_vs_Explicit_PP_10min.pptx
+++ b/docs/03_Implicit_vs_Explicit_PP_10min.pptx
@@ -4,6 +4,9 @@
   <p:sldMasterIdLst>
     <p:sldMasterId id="2147483648" r:id="rId1"/>
   </p:sldMasterIdLst>
+  <p:notesMasterIdLst>
+    <p:notesMasterId r:id="rId12"/>
+  </p:notesMasterIdLst>
   <p:sldIdLst>
     <p:sldId id="256" r:id="rId2"/>
     <p:sldId id="257" r:id="rId3"/>
@@ -16,10 +19,7 @@
     <p:sldId id="264" r:id="rId10"/>
     <p:sldId id="265" r:id="rId11"/>
   </p:sldIdLst>
-  <p:notesMasterIdLst>
-    <p:notesMasterId r:id="rId12"/>
-  </p:notesMasterIdLst>
-  <p:sldSz cx="9144000" cy="5143500"/>
+  <p:sldSz cx="9144000" cy="5143500" type="screen16x9"/>
   <p:notesSz cx="5143500" cy="9144000"/>
   <p:defaultTextStyle>
     <a:lvl1pPr marL="0" algn="l" defTabSz="914400" rtl="0" eaLnBrk="1" latinLnBrk="0" hangingPunct="1">
@@ -113,6 +113,11 @@
       </a:defRPr>
     </a:lvl9pPr>
   </p:defaultTextStyle>
+  <p:extLst>
+    <p:ext uri="{EFAFB233-063F-42B5-8137-9DF3F51BA10A}">
+      <p15:sldGuideLst xmlns:p15="http://schemas.microsoft.com/office/powerpoint/2012/main"/>
+    </p:ext>
+  </p:extLst>
 </p:presentation>
 </file>
 
@@ -138,234 +143,10 @@
           <a:chExt cx="0" cy="0"/>
         </a:xfrm>
       </p:grpSpPr>
-      <p:sp>
-        <p:nvSpPr>
-          <p:cNvPr id="2" name="Header Placeholder 1"/>
-          <p:cNvSpPr>
-            <a:spLocks noGrp="1"/>
-          </p:cNvSpPr>
-          <p:nvPr>
-            <p:ph type="hdr" sz="quarter"/>
-          </p:nvPr>
-        </p:nvSpPr>
-        <p:spPr>
-          <a:xfrm>
-            <a:off x="0" y="0"/>
-            <a:ext cx="2971800" cy="458788"/>
-          </a:xfrm>
-          <a:prstGeom prst="rect">
-            <a:avLst/>
-          </a:prstGeom>
-        </p:spPr>
-        <p:txBody>
-          <a:bodyPr vert="horz" lIns="91440" tIns="45720" rIns="91440" bIns="45720" rtlCol="0"/>
-          <a:lstStyle>
-            <a:lvl1pPr algn="l">
-              <a:defRPr sz="1200"/>
-            </a:lvl1pPr>
-          </a:lstStyle>
-          <a:p>
-            <a:endParaRPr lang="en-US"/>
-          </a:p>
-        </p:txBody>
-      </p:sp>
-      <p:sp>
-        <p:nvSpPr>
-          <p:cNvPr id="3" name="Date Placeholder 2"/>
-          <p:cNvSpPr>
-            <a:spLocks noGrp="1"/>
-          </p:cNvSpPr>
-          <p:nvPr>
-            <p:ph type="dt" idx="1"/>
-          </p:nvPr>
-        </p:nvSpPr>
-        <p:spPr>
-          <a:xfrm>
-            <a:off x="3884613" y="0"/>
-            <a:ext cx="2971800" cy="458788"/>
-          </a:xfrm>
-          <a:prstGeom prst="rect">
-            <a:avLst/>
-          </a:prstGeom>
-        </p:spPr>
-        <p:txBody>
-          <a:bodyPr vert="horz" lIns="91440" tIns="45720" rIns="91440" bIns="45720" rtlCol="0"/>
-          <a:lstStyle>
-            <a:lvl1pPr algn="r">
-              <a:defRPr sz="1200"/>
-            </a:lvl1pPr>
-          </a:lstStyle>
-          <a:p>
-            <a:fld id="{5282F153-3F37-0F45-9E97-73ACFA13230C}" type="datetimeFigureOut">
-              <a:rPr lang="en-US"/>
-              <a:t>7/23/19</a:t>
-            </a:fld>
-            <a:endParaRPr lang="en-US"/>
-          </a:p>
-        </p:txBody>
-      </p:sp>
-      <p:sp>
-        <p:nvSpPr>
-          <p:cNvPr id="4" name="Slide Image Placeholder 3"/>
-          <p:cNvSpPr>
-            <a:spLocks noGrp="1" noRot="1" noChangeAspect="1"/>
-          </p:cNvSpPr>
-          <p:nvPr>
-            <p:ph type="sldImg" idx="2"/>
-          </p:nvPr>
-        </p:nvSpPr>
-        <p:spPr>
-          <a:xfrm>
-            <a:off x="685800" y="1143000"/>
-            <a:ext cx="5486400" cy="3086100"/>
-          </a:xfrm>
-          <a:prstGeom prst="rect">
-            <a:avLst/>
-          </a:prstGeom>
-          <a:noFill/>
-          <a:ln w="12700">
-            <a:solidFill>
-              <a:prstClr val="black"/>
-            </a:solidFill>
-          </a:ln>
-        </p:spPr>
-        <p:txBody>
-          <a:bodyPr vert="horz" lIns="91440" tIns="45720" rIns="91440" bIns="45720" rtlCol="0" anchor="ctr"/>
-          <a:lstStyle/>
-          <a:p>
-            <a:endParaRPr lang="en-US"/>
-          </a:p>
-        </p:txBody>
-      </p:sp>
-      <p:sp>
-        <p:nvSpPr>
-          <p:cNvPr id="5" name="Notes Placeholder 4"/>
-          <p:cNvSpPr>
-            <a:spLocks noGrp="1"/>
-          </p:cNvSpPr>
-          <p:nvPr>
-            <p:ph type="body" sz="quarter" idx="3"/>
-          </p:nvPr>
-        </p:nvSpPr>
-        <p:spPr>
-          <a:xfrm>
-            <a:off x="685800" y="4400550"/>
-            <a:ext cx="5486400" cy="3600450"/>
-          </a:xfrm>
-          <a:prstGeom prst="rect">
-            <a:avLst/>
-          </a:prstGeom>
-        </p:spPr>
-        <p:txBody>
-          <a:bodyPr vert="horz" lIns="91440" tIns="45720" rIns="91440" bIns="45720" rtlCol="0"/>
-          <a:lstStyle/>
-          <a:p>
-            <a:pPr lvl="0"/>
-            <a:r>
-              <a:rPr lang="en-US"/>
-              <a:t>Click to edit Master text styles</a:t>
-            </a:r>
-          </a:p>
-          <a:p>
-            <a:pPr lvl="1"/>
-            <a:r>
-              <a:rPr lang="en-US"/>
-              <a:t>Second level</a:t>
-            </a:r>
-          </a:p>
-          <a:p>
-            <a:pPr lvl="2"/>
-            <a:r>
-              <a:rPr lang="en-US"/>
-              <a:t>Third level</a:t>
-            </a:r>
-          </a:p>
-          <a:p>
-            <a:pPr lvl="3"/>
-            <a:r>
-              <a:rPr lang="en-US"/>
-              <a:t>Fourth level</a:t>
-            </a:r>
-          </a:p>
-          <a:p>
-            <a:pPr lvl="4"/>
-            <a:r>
-              <a:rPr lang="en-US"/>
-              <a:t>Fifth level</a:t>
-            </a:r>
-          </a:p>
-        </p:txBody>
-      </p:sp>
-      <p:sp>
-        <p:nvSpPr>
-          <p:cNvPr id="6" name="Footer Placeholder 5"/>
-          <p:cNvSpPr>
-            <a:spLocks noGrp="1"/>
-          </p:cNvSpPr>
-          <p:nvPr>
-            <p:ph type="ftr" sz="quarter" idx="4"/>
-          </p:nvPr>
-        </p:nvSpPr>
-        <p:spPr>
-          <a:xfrm>
-            <a:off x="0" y="8685213"/>
-            <a:ext cx="2971800" cy="458787"/>
-          </a:xfrm>
-          <a:prstGeom prst="rect">
-            <a:avLst/>
-          </a:prstGeom>
-        </p:spPr>
-        <p:txBody>
-          <a:bodyPr vert="horz" lIns="91440" tIns="45720" rIns="91440" bIns="45720" rtlCol="0" anchor="b"/>
-          <a:lstStyle>
-            <a:lvl1pPr algn="l">
-              <a:defRPr sz="1200"/>
-            </a:lvl1pPr>
-          </a:lstStyle>
-          <a:p>
-            <a:endParaRPr lang="en-US"/>
-          </a:p>
-        </p:txBody>
-      </p:sp>
-      <p:sp>
-        <p:nvSpPr>
-          <p:cNvPr id="7" name="Slide Number Placeholder 6"/>
-          <p:cNvSpPr>
-            <a:spLocks noGrp="1"/>
-          </p:cNvSpPr>
-          <p:nvPr>
-            <p:ph type="sldNum" sz="quarter" idx="5"/>
-          </p:nvPr>
-        </p:nvSpPr>
-        <p:spPr>
-          <a:xfrm>
-            <a:off x="3884613" y="8685213"/>
-            <a:ext cx="2971800" cy="458787"/>
-          </a:xfrm>
-          <a:prstGeom prst="rect">
-            <a:avLst/>
-          </a:prstGeom>
-        </p:spPr>
-        <p:txBody>
-          <a:bodyPr vert="horz" lIns="91440" tIns="45720" rIns="91440" bIns="45720" rtlCol="0" anchor="b"/>
-          <a:lstStyle>
-            <a:lvl1pPr algn="r">
-              <a:defRPr sz="1200"/>
-            </a:lvl1pPr>
-          </a:lstStyle>
-          <a:p>
-            <a:fld id="{CE5E9CC1-C706-0F49-92D6-E571CC5EEA8F}" type="slidenum">
-              <a:rPr lang="en-US"/>
-              <a:t>‹#›</a:t>
-            </a:fld>
-            <a:endParaRPr lang="en-US"/>
-          </a:p>
-        </p:txBody>
-      </p:sp>
     </p:spTree>
     <p:extLst>
       <p:ext uri="{BB962C8B-B14F-4D97-AF65-F5344CB8AC3E}">
-        <p14:creationId xmlns:p14="http://schemas.microsoft.com/office/powerpoint/2010/main" val="1024086991"/>
+        <p14:creationId xmlns:p14="http://schemas.microsoft.com/office/powerpoint/2010/main" val="809588643"/>
       </p:ext>
     </p:extLst>
   </p:cSld>
@@ -513,7 +294,6 @@
               <a:rPr lang="en-US" dirty="0"/>
               <a:t>This is a 10-minute talk that builds directly on the Goldilocks Principle and pushes into territory where I think PP needs supplementation. I want to be clear: this isn't an attack on PP. It's a proposal for what PP needs ADDED to it to handle a distinction that matters enormously for architecture — the difference between implicit and explicit processing. Andy, I'm genuinely uncertain about some of this and want your input.</a:t>
             </a:r>
-            <a:endParaRPr lang="en-US" dirty="0"/>
           </a:p>
         </p:txBody>
       </p:sp>
@@ -597,10 +377,6 @@
           <a:bodyPr/>
           <a:lstStyle/>
           <a:p>
-            <a:r>
-              <a:rPr lang="en-US" dirty="0"/>
-              <a:t/>
-            </a:r>
             <a:endParaRPr lang="en-US" dirty="0"/>
           </a:p>
         </p:txBody>
@@ -689,7 +465,6 @@
               <a:rPr lang="en-US" dirty="0"/>
               <a:t>Here's the observation in its simplest form. Think about two activities. Walking through a lively market — browsing, exploring. Processing is parallel, automatic, effortless. A rich environment feels GOOD. This is implicit processing, and Goldilocks applies. Now think about writing a mathematical proof. Sustained, deliberate, step-by-step reasoning. Processing is serial, effortful, fragile. A rich environment feels DISTRACTING. ANY interruption collapses your chain of reasoning. This is explicit processing — and the Goldilocks principle is WRONG for it. You don't want moderate PE. You want MINIMUM PE variance. These two activities require OPPOSITE environmental profiles. This is the architectural problem that PP must solve.</a:t>
             </a:r>
-            <a:endParaRPr lang="en-US" dirty="0"/>
           </a:p>
         </p:txBody>
       </p:sp>
@@ -777,7 +552,6 @@
               <a:rPr lang="en-US" dirty="0"/>
               <a:t>PP handles implicit processing beautifully. Attention is precision-weighting. Perception is hierarchical Bayesian inference. All automatic, parallel, continuous. But three things in explicit processing are harder for PP to explain. First, goal-directed attention — not stimulus-driven precision, but CHOOSING what to attend to. Second, compositional reasoning — novel variable binding that goes beyond pattern matching. Third, the serial bottleneck — why can we only maintain one chain of reasoning at a time? Andy's response in Surfing Uncertainty is that deliberate attention IS precision-weighting from higher hierarchical levels. Goals set precision on lower levels. Our concern — and I say this respectfully — is that this pushes the explanatory burden up the hierarchy without explaining where goal representations come from. The homunculus hasn't been dissolved; it's been promoted to management.</a:t>
             </a:r>
-            <a:endParaRPr lang="en-US" dirty="0"/>
           </a:p>
         </p:txBody>
       </p:sp>
@@ -865,7 +639,6 @@
               <a:rPr lang="en-US" dirty="0"/>
               <a:t>Here's the proposal in table form. Two computational regimes with different processing modes, different mechanisms, different capacities, and — crucially — different environmental requirements. The implicit regime is what Goldilocks captures: parallel, automatic, sensitive to PE mean. The explicit regime is something different: serial, effortful, sensitive to PE variance. The architectural challenge: a building must support BOTH. And the optimal environment for each is nearly opposite.</a:t>
             </a:r>
-            <a:endParaRPr lang="en-US" dirty="0"/>
           </a:p>
         </p:txBody>
       </p:sp>
@@ -953,7 +726,6 @@
               <a:rPr lang="en-US" dirty="0"/>
               <a:t>The switching mechanism is the LC-NE system — Aston-Jones and Cohen's adaptive gain theory. In tonic mode, moderate steady NE supports sustained workspace maintenance — that's the explicit regime. In phasic mode, burst firing on salient events resets cortical gain globally, collapsing workspace representations — that switches to the implicit regime. The critical point for architecture: unpredictable environmental events trigger phasic bursts. Every salient PE spike is a potential workspace collapse. This is why PE VARIANCE, not mean, is the key variable for explicit processing. A room with steady moderate noise is better for deep work than a room with quiet punctuated by occasional loud events — even if the AVERAGE noise level is identical.</a:t>
             </a:r>
-            <a:endParaRPr lang="en-US" dirty="0"/>
           </a:p>
         </p:txBody>
       </p:sp>
@@ -1041,7 +813,6 @@
               <a:rPr lang="en-US" dirty="0"/>
               <a:t>Here's why this matters for architecture. Four puzzles that the two-regime framework explains and standard PP doesn't. Why are cafes good for writing? Low PE variance plus moderate PE mean — both regimes served. Why do open offices kill focus but seem fine for casual tasks? High PE variance collapses explicit regime, but PE mean is fine for implicit. Why do translucent partitions fail where opaque ones succeed? Translucent triggers subthreshold conflict monitoring — cumulative cost. And why does personal control help more than satisfaction alone? Self-generated changes have near-zero PE. Each of these requires the mean/variance distinction. Minimize-PE can't explain any of them.</a:t>
             </a:r>
-            <a:endParaRPr lang="en-US" dirty="0"/>
           </a:p>
         </p:txBody>
       </p:sp>
@@ -1129,7 +900,6 @@
               <a:rPr lang="en-US" dirty="0"/>
               <a:t>We identify three types of interruption with distinct mechanisms. Type 1, phasic environmental — a sudden sound triggers LC-NE burst and workspace collapse. Recovery takes 10-23 minutes. Type 2, semantic intrusion — overheard speech creates competing compositional content. WORSE than Type 1 because the intruding content is structured. Type 3, social interruption — four-way demand on the serial bottleneck, with mandatory high precision on social stimuli. Open offices produce all three simultaneously. This is the mechanistic explanation for Bernstein and Turban's finding — the 70% reduction in face-to-face interaction. People WITHDRAW to protect their workspace.</a:t>
             </a:r>
-            <a:endParaRPr lang="en-US" dirty="0"/>
           </a:p>
         </p:txBody>
       </p:sp>
@@ -1217,7 +987,6 @@
               <a:rPr lang="en-US" dirty="0"/>
               <a:t>Here's a key insight from the two-regime framework: WHEN you're interrupted matters more than how. I'm calling it the fragility curve. Phase 1, the first 5 minutes — maximally fragile. You're building the workspace representation. Any interruption forces complete restart. Phase 2, 5-15 minutes — elaboration, moderately fragile. Phase 3, 15-25 minutes — consolidation, redundant support developing. Phase 4, 25+ minutes — flow state, relatively robust. The architectural principle: uninterrupted time is a nonlinear resource. The first 5 minutes are disproportionately valuable. A space that guarantees even brief reliable protection during that phase will support more total explicit processing than a space with longer but unreliable protection.</a:t>
             </a:r>
-            <a:endParaRPr lang="en-US" dirty="0"/>
           </a:p>
         </p:txBody>
       </p:sp>
@@ -1305,7 +1074,6 @@
               <a:rPr lang="en-US" dirty="0"/>
               <a:t>Here's the design matrix. PE mean on one axis, PE variance on the other. Top-left: moderate mean, low variance — the sweet spot. Library reading rooms, well-designed private offices. Both regimes served. Top-right: high mean, low variance — creative spaces. Cafes, workshops. Implicit regime thrives. Bottom-left: low mean, low variance — boring. Focus pods with blank walls. Explicit protected but implicit starved. Bottom-right: any mean, high variance — catastrophic. Open offices, hospital ICUs. Unpredictable spikes collapse everything. The variance axis is INVISIBLE in standard environmental psychology but it dominates explicit-regime performance. This is why open offices 'should' work by mean-PE logic but don't — the variance kills explicit processing.</a:t>
             </a:r>
-            <a:endParaRPr lang="en-US" dirty="0"/>
           </a:p>
         </p:txBody>
       </p:sp>
@@ -1378,6 +1146,11 @@
 <file path=ppt/slideMasters/slideMaster1.xml><?xml version="1.0" encoding="utf-8"?>
 <p:sldMaster xmlns:a="http://schemas.openxmlformats.org/drawingml/2006/main" xmlns:r="http://schemas.openxmlformats.org/officeDocument/2006/relationships" xmlns:p="http://schemas.openxmlformats.org/presentationml/2006/main">
   <p:cSld>
+    <p:bg>
+      <p:bgRef idx="1001">
+        <a:schemeClr val="bg1"/>
+      </p:bgRef>
+    </p:bg>
     <p:spTree>
       <p:nvGrpSpPr>
         <p:cNvPr id="1" name=""/>
@@ -1660,6 +1433,7 @@
         <a:solidFill>
           <a:srgbClr val="1B2A4A"/>
         </a:solidFill>
+        <a:effectLst/>
       </p:bgPr>
     </p:bg>
     <p:spTree>
@@ -1695,6 +1469,13 @@
           </a:solidFill>
           <a:ln/>
         </p:spPr>
+        <p:txBody>
+          <a:bodyPr/>
+          <a:lstStyle/>
+          <a:p>
+            <a:endParaRPr lang="en-US"/>
+          </a:p>
+        </p:txBody>
       </p:sp>
       <p:sp>
         <p:nvSpPr>
@@ -1717,7 +1498,7 @@
           <a:bodyPr wrap="square" rtlCol="0" anchor="ctr"/>
           <a:lstStyle/>
           <a:p>
-            <a:pPr indent="0" marL="0">
+            <a:pPr marL="0" indent="0">
               <a:buNone/>
             </a:pPr>
             <a:r>
@@ -1756,7 +1537,7 @@
           <a:bodyPr wrap="square" rtlCol="0" anchor="ctr"/>
           <a:lstStyle/>
           <a:p>
-            <a:pPr indent="0" marL="0">
+            <a:pPr marL="0" indent="0">
               <a:buNone/>
             </a:pPr>
             <a:r>
@@ -1773,7 +1554,7 @@
             <a:endParaRPr lang="en-US" sz="2000" dirty="0"/>
           </a:p>
           <a:p>
-            <a:pPr indent="0" marL="0">
+            <a:pPr marL="0" indent="0">
               <a:buNone/>
             </a:pPr>
             <a:r>
@@ -1812,7 +1593,7 @@
           <a:bodyPr wrap="square" rtlCol="0" anchor="ctr"/>
           <a:lstStyle/>
           <a:p>
-            <a:pPr indent="0" marL="0">
+            <a:pPr marL="0" indent="0">
               <a:buNone/>
             </a:pPr>
             <a:r>
@@ -1851,7 +1632,7 @@
           <a:bodyPr wrap="square" rtlCol="0" anchor="ctr"/>
           <a:lstStyle/>
           <a:p>
-            <a:pPr indent="0" marL="0">
+            <a:pPr marL="0" indent="0">
               <a:buNone/>
             </a:pPr>
             <a:r>
@@ -1885,6 +1666,7 @@
         <a:solidFill>
           <a:srgbClr val="1B2A4A"/>
         </a:solidFill>
+        <a:effectLst/>
       </p:bgPr>
     </p:bg>
     <p:spTree>
@@ -1920,6 +1702,13 @@
           </a:solidFill>
           <a:ln/>
         </p:spPr>
+        <p:txBody>
+          <a:bodyPr/>
+          <a:lstStyle/>
+          <a:p>
+            <a:endParaRPr lang="en-US"/>
+          </a:p>
+        </p:txBody>
       </p:sp>
       <p:sp>
         <p:nvSpPr>
@@ -1942,7 +1731,7 @@
           <a:bodyPr wrap="square" rtlCol="0" anchor="ctr"/>
           <a:lstStyle/>
           <a:p>
-            <a:pPr indent="0" marL="0">
+            <a:pPr marL="0" indent="0">
               <a:buNone/>
             </a:pPr>
             <a:r>
@@ -1981,7 +1770,7 @@
           <a:bodyPr wrap="square" rtlCol="0" anchor="ctr"/>
           <a:lstStyle/>
           <a:p>
-            <a:pPr indent="0" marL="0">
+            <a:pPr marL="0" indent="0">
               <a:buNone/>
             </a:pPr>
             <a:r>
@@ -1998,13 +1787,13 @@
             <a:endParaRPr lang="en-US" sz="1600" dirty="0"/>
           </a:p>
           <a:p>
-            <a:pPr indent="0" marL="0">
+            <a:pPr marL="0" indent="0">
               <a:buNone/>
             </a:pPr>
             <a:endParaRPr lang="en-US" sz="1600" dirty="0"/>
           </a:p>
           <a:p>
-            <a:pPr indent="0" marL="0">
+            <a:pPr marL="0" indent="0">
               <a:buNone/>
             </a:pPr>
             <a:r>
@@ -2021,7 +1810,7 @@
             <a:endParaRPr lang="en-US" sz="1600" dirty="0"/>
           </a:p>
           <a:p>
-            <a:pPr indent="0" marL="0">
+            <a:pPr marL="0" indent="0">
               <a:buNone/>
             </a:pPr>
             <a:r>
@@ -2038,13 +1827,13 @@
             <a:endParaRPr lang="en-US" sz="1600" dirty="0"/>
           </a:p>
           <a:p>
-            <a:pPr indent="0" marL="0">
+            <a:pPr marL="0" indent="0">
               <a:buNone/>
             </a:pPr>
             <a:endParaRPr lang="en-US" sz="1600" dirty="0"/>
           </a:p>
           <a:p>
-            <a:pPr indent="0" marL="0">
+            <a:pPr marL="0" indent="0">
               <a:buNone/>
             </a:pPr>
             <a:r>
@@ -2061,7 +1850,7 @@
             <a:endParaRPr lang="en-US" sz="1600" dirty="0"/>
           </a:p>
           <a:p>
-            <a:pPr indent="0" marL="0">
+            <a:pPr marL="0" indent="0">
               <a:buNone/>
             </a:pPr>
             <a:r>
@@ -2078,13 +1867,13 @@
             <a:endParaRPr lang="en-US" sz="1600" dirty="0"/>
           </a:p>
           <a:p>
-            <a:pPr indent="0" marL="0">
+            <a:pPr marL="0" indent="0">
               <a:buNone/>
             </a:pPr>
             <a:endParaRPr lang="en-US" sz="1600" dirty="0"/>
           </a:p>
           <a:p>
-            <a:pPr indent="0" marL="0">
+            <a:pPr marL="0" indent="0">
               <a:buNone/>
             </a:pPr>
             <a:r>
@@ -2101,7 +1890,7 @@
             <a:endParaRPr lang="en-US" sz="1600" dirty="0"/>
           </a:p>
           <a:p>
-            <a:pPr indent="0" marL="0">
+            <a:pPr marL="0" indent="0">
               <a:buNone/>
             </a:pPr>
             <a:r>
@@ -2140,7 +1929,7 @@
           <a:bodyPr wrap="square" rtlCol="0" anchor="ctr"/>
           <a:lstStyle/>
           <a:p>
-            <a:pPr indent="0" marL="0">
+            <a:pPr marL="0" indent="0">
               <a:buNone/>
             </a:pPr>
             <a:r>
@@ -2179,7 +1968,7 @@
           <a:bodyPr wrap="square" rtlCol="0" anchor="ctr"/>
           <a:lstStyle/>
           <a:p>
-            <a:pPr indent="0" marL="0">
+            <a:pPr marL="0" indent="0">
               <a:buNone/>
             </a:pPr>
             <a:r>
@@ -2213,6 +2002,7 @@
         <a:solidFill>
           <a:srgbClr val="F5F0E8"/>
         </a:solidFill>
+        <a:effectLst/>
       </p:bgPr>
     </p:bg>
     <p:spTree>
@@ -2248,6 +2038,13 @@
           </a:solidFill>
           <a:ln/>
         </p:spPr>
+        <p:txBody>
+          <a:bodyPr/>
+          <a:lstStyle/>
+          <a:p>
+            <a:endParaRPr lang="en-US"/>
+          </a:p>
+        </p:txBody>
       </p:sp>
       <p:sp>
         <p:nvSpPr>
@@ -2270,7 +2067,7 @@
           <a:bodyPr wrap="square" rtlCol="0" anchor="ctr"/>
           <a:lstStyle/>
           <a:p>
-            <a:pPr indent="0" marL="0">
+            <a:pPr marL="0" indent="0">
               <a:buNone/>
             </a:pPr>
             <a:r>
@@ -2309,7 +2106,7 @@
           <a:bodyPr wrap="square" rtlCol="0" anchor="ctr"/>
           <a:lstStyle/>
           <a:p>
-            <a:pPr indent="0" marL="0">
+            <a:pPr marL="0" indent="0">
               <a:buNone/>
             </a:pPr>
             <a:r>
@@ -2326,7 +2123,7 @@
             <a:endParaRPr lang="en-US" sz="2800" dirty="0"/>
           </a:p>
           <a:p>
-            <a:pPr indent="0" marL="0">
+            <a:pPr marL="0" indent="0">
               <a:buNone/>
             </a:pPr>
             <a:r>
@@ -2365,7 +2162,7 @@
           <a:bodyPr wrap="square" rtlCol="0" anchor="ctr"/>
           <a:lstStyle/>
           <a:p>
-            <a:pPr indent="0" marL="0">
+            <a:pPr marL="0" indent="0">
               <a:buNone/>
             </a:pPr>
             <a:r>
@@ -2402,6 +2199,13 @@
           </a:solidFill>
           <a:ln/>
         </p:spPr>
+        <p:txBody>
+          <a:bodyPr/>
+          <a:lstStyle/>
+          <a:p>
+            <a:endParaRPr lang="en-US"/>
+          </a:p>
+        </p:txBody>
       </p:sp>
       <p:sp>
         <p:nvSpPr>
@@ -2424,7 +2228,7 @@
           <a:bodyPr wrap="square" rtlCol="0" anchor="ctr"/>
           <a:lstStyle/>
           <a:p>
-            <a:pPr indent="0" marL="0">
+            <a:pPr marL="0" indent="0">
               <a:buNone/>
             </a:pPr>
             <a:r>
@@ -2463,7 +2267,7 @@
           <a:bodyPr wrap="square" rtlCol="0" anchor="t"/>
           <a:lstStyle/>
           <a:p>
-            <a:pPr indent="0" marL="0">
+            <a:pPr marL="0" indent="0">
               <a:buNone/>
             </a:pPr>
             <a:r>
@@ -2480,7 +2284,7 @@
             <a:endParaRPr lang="en-US" sz="1200" dirty="0"/>
           </a:p>
           <a:p>
-            <a:pPr indent="0" marL="0">
+            <a:pPr marL="0" indent="0">
               <a:buNone/>
             </a:pPr>
             <a:r>
@@ -2497,7 +2301,7 @@
             <a:endParaRPr lang="en-US" sz="1200" dirty="0"/>
           </a:p>
           <a:p>
-            <a:pPr indent="0" marL="0">
+            <a:pPr marL="0" indent="0">
               <a:buNone/>
             </a:pPr>
             <a:r>
@@ -2514,7 +2318,7 @@
             <a:endParaRPr lang="en-US" sz="1200" dirty="0"/>
           </a:p>
           <a:p>
-            <a:pPr indent="0" marL="0">
+            <a:pPr marL="0" indent="0">
               <a:buNone/>
             </a:pPr>
             <a:r>
@@ -2531,13 +2335,13 @@
             <a:endParaRPr lang="en-US" sz="1200" dirty="0"/>
           </a:p>
           <a:p>
-            <a:pPr indent="0" marL="0">
+            <a:pPr marL="0" indent="0">
               <a:buNone/>
             </a:pPr>
             <a:endParaRPr lang="en-US" sz="1200" dirty="0"/>
           </a:p>
           <a:p>
-            <a:pPr indent="0" marL="0">
+            <a:pPr marL="0" indent="0">
               <a:buNone/>
             </a:pPr>
             <a:r>
@@ -2554,13 +2358,13 @@
             <a:endParaRPr lang="en-US" sz="1200" dirty="0"/>
           </a:p>
           <a:p>
-            <a:pPr indent="0" marL="0">
+            <a:pPr marL="0" indent="0">
               <a:buNone/>
             </a:pPr>
             <a:endParaRPr lang="en-US" sz="1200" dirty="0"/>
           </a:p>
           <a:p>
-            <a:pPr indent="0" marL="0">
+            <a:pPr marL="0" indent="0">
               <a:buNone/>
             </a:pPr>
             <a:r>
@@ -2597,6 +2401,13 @@
           </a:solidFill>
           <a:ln/>
         </p:spPr>
+        <p:txBody>
+          <a:bodyPr/>
+          <a:lstStyle/>
+          <a:p>
+            <a:endParaRPr lang="en-US"/>
+          </a:p>
+        </p:txBody>
       </p:sp>
       <p:sp>
         <p:nvSpPr>
@@ -2619,7 +2430,7 @@
           <a:bodyPr wrap="square" rtlCol="0" anchor="ctr"/>
           <a:lstStyle/>
           <a:p>
-            <a:pPr indent="0" marL="0">
+            <a:pPr marL="0" indent="0">
               <a:buNone/>
             </a:pPr>
             <a:r>
@@ -2658,7 +2469,7 @@
           <a:bodyPr wrap="square" rtlCol="0" anchor="t"/>
           <a:lstStyle/>
           <a:p>
-            <a:pPr indent="0" marL="0">
+            <a:pPr marL="0" indent="0">
               <a:buNone/>
             </a:pPr>
             <a:r>
@@ -2675,7 +2486,7 @@
             <a:endParaRPr lang="en-US" sz="1200" dirty="0"/>
           </a:p>
           <a:p>
-            <a:pPr indent="0" marL="0">
+            <a:pPr marL="0" indent="0">
               <a:buNone/>
             </a:pPr>
             <a:r>
@@ -2692,7 +2503,7 @@
             <a:endParaRPr lang="en-US" sz="1200" dirty="0"/>
           </a:p>
           <a:p>
-            <a:pPr indent="0" marL="0">
+            <a:pPr marL="0" indent="0">
               <a:buNone/>
             </a:pPr>
             <a:r>
@@ -2709,7 +2520,7 @@
             <a:endParaRPr lang="en-US" sz="1200" dirty="0"/>
           </a:p>
           <a:p>
-            <a:pPr indent="0" marL="0">
+            <a:pPr marL="0" indent="0">
               <a:buNone/>
             </a:pPr>
             <a:r>
@@ -2726,13 +2537,13 @@
             <a:endParaRPr lang="en-US" sz="1200" dirty="0"/>
           </a:p>
           <a:p>
-            <a:pPr indent="0" marL="0">
+            <a:pPr marL="0" indent="0">
               <a:buNone/>
             </a:pPr>
             <a:endParaRPr lang="en-US" sz="1200" dirty="0"/>
           </a:p>
           <a:p>
-            <a:pPr indent="0" marL="0">
+            <a:pPr marL="0" indent="0">
               <a:buNone/>
             </a:pPr>
             <a:r>
@@ -2749,13 +2560,13 @@
             <a:endParaRPr lang="en-US" sz="1200" dirty="0"/>
           </a:p>
           <a:p>
-            <a:pPr indent="0" marL="0">
+            <a:pPr marL="0" indent="0">
               <a:buNone/>
             </a:pPr>
             <a:endParaRPr lang="en-US" sz="1200" dirty="0"/>
           </a:p>
           <a:p>
-            <a:pPr indent="0" marL="0">
+            <a:pPr marL="0" indent="0">
               <a:buNone/>
             </a:pPr>
             <a:r>
@@ -2794,7 +2605,7 @@
           <a:bodyPr wrap="square" rtlCol="0" anchor="ctr"/>
           <a:lstStyle/>
           <a:p>
-            <a:pPr indent="0" marL="0">
+            <a:pPr marL="0" indent="0">
               <a:buNone/>
             </a:pPr>
             <a:r>
@@ -2833,7 +2644,7 @@
           <a:bodyPr wrap="square" rtlCol="0" anchor="ctr"/>
           <a:lstStyle/>
           <a:p>
-            <a:pPr indent="0" marL="0">
+            <a:pPr marL="0" indent="0">
               <a:buNone/>
             </a:pPr>
             <a:r>
@@ -2867,6 +2678,7 @@
         <a:solidFill>
           <a:srgbClr val="F5F0E8"/>
         </a:solidFill>
+        <a:effectLst/>
       </p:bgPr>
     </p:bg>
     <p:spTree>
@@ -2902,6 +2714,13 @@
           </a:solidFill>
           <a:ln/>
         </p:spPr>
+        <p:txBody>
+          <a:bodyPr/>
+          <a:lstStyle/>
+          <a:p>
+            <a:endParaRPr lang="en-US"/>
+          </a:p>
+        </p:txBody>
       </p:sp>
       <p:sp>
         <p:nvSpPr>
@@ -2924,7 +2743,7 @@
           <a:bodyPr wrap="square" rtlCol="0" anchor="ctr"/>
           <a:lstStyle/>
           <a:p>
-            <a:pPr indent="0" marL="0">
+            <a:pPr marL="0" indent="0">
               <a:buNone/>
             </a:pPr>
             <a:r>
@@ -2963,7 +2782,7 @@
           <a:bodyPr wrap="square" rtlCol="0" anchor="ctr"/>
           <a:lstStyle/>
           <a:p>
-            <a:pPr indent="0" marL="0">
+            <a:pPr marL="0" indent="0">
               <a:buNone/>
             </a:pPr>
             <a:r>
@@ -2980,7 +2799,7 @@
             <a:endParaRPr lang="en-US" sz="2600" dirty="0"/>
           </a:p>
           <a:p>
-            <a:pPr indent="0" marL="0">
+            <a:pPr marL="0" indent="0">
               <a:buNone/>
             </a:pPr>
             <a:r>
@@ -3017,6 +2836,13 @@
           </a:solidFill>
           <a:ln/>
         </p:spPr>
+        <p:txBody>
+          <a:bodyPr/>
+          <a:lstStyle/>
+          <a:p>
+            <a:endParaRPr lang="en-US"/>
+          </a:p>
+        </p:txBody>
       </p:sp>
       <p:sp>
         <p:nvSpPr>
@@ -3039,7 +2865,7 @@
           <a:bodyPr wrap="square" rtlCol="0" anchor="ctr"/>
           <a:lstStyle/>
           <a:p>
-            <a:pPr indent="0" marL="0">
+            <a:pPr marL="0" indent="0">
               <a:buNone/>
             </a:pPr>
             <a:r>
@@ -3078,7 +2904,7 @@
           <a:bodyPr wrap="square" rtlCol="0" anchor="t"/>
           <a:lstStyle/>
           <a:p>
-            <a:pPr indent="0" marL="0">
+            <a:pPr marL="0" indent="0">
               <a:buNone/>
             </a:pPr>
             <a:r>
@@ -3095,7 +2921,7 @@
             <a:endParaRPr lang="en-US" sz="1100" dirty="0"/>
           </a:p>
           <a:p>
-            <a:pPr indent="0" marL="0">
+            <a:pPr marL="0" indent="0">
               <a:buNone/>
             </a:pPr>
             <a:r>
@@ -3112,7 +2938,7 @@
             <a:endParaRPr lang="en-US" sz="1100" dirty="0"/>
           </a:p>
           <a:p>
-            <a:pPr indent="0" marL="0">
+            <a:pPr marL="0" indent="0">
               <a:buNone/>
             </a:pPr>
             <a:r>
@@ -3129,7 +2955,7 @@
             <a:endParaRPr lang="en-US" sz="1100" dirty="0"/>
           </a:p>
           <a:p>
-            <a:pPr indent="0" marL="0">
+            <a:pPr marL="0" indent="0">
               <a:buNone/>
             </a:pPr>
             <a:r>
@@ -3146,13 +2972,13 @@
             <a:endParaRPr lang="en-US" sz="1100" dirty="0"/>
           </a:p>
           <a:p>
-            <a:pPr indent="0" marL="0">
+            <a:pPr marL="0" indent="0">
               <a:buNone/>
             </a:pPr>
             <a:endParaRPr lang="en-US" sz="1100" dirty="0"/>
           </a:p>
           <a:p>
-            <a:pPr indent="0" marL="0">
+            <a:pPr marL="0" indent="0">
               <a:buNone/>
             </a:pPr>
             <a:r>
@@ -3189,6 +3015,13 @@
           </a:solidFill>
           <a:ln/>
         </p:spPr>
+        <p:txBody>
+          <a:bodyPr/>
+          <a:lstStyle/>
+          <a:p>
+            <a:endParaRPr lang="en-US"/>
+          </a:p>
+        </p:txBody>
       </p:sp>
       <p:sp>
         <p:nvSpPr>
@@ -3211,7 +3044,7 @@
           <a:bodyPr wrap="square" rtlCol="0" anchor="ctr"/>
           <a:lstStyle/>
           <a:p>
-            <a:pPr indent="0" marL="0">
+            <a:pPr marL="0" indent="0">
               <a:buNone/>
             </a:pPr>
             <a:r>
@@ -3250,7 +3083,7 @@
           <a:bodyPr wrap="square" rtlCol="0" anchor="t"/>
           <a:lstStyle/>
           <a:p>
-            <a:pPr indent="0" marL="0">
+            <a:pPr marL="0" indent="0">
               <a:buNone/>
             </a:pPr>
             <a:r>
@@ -3267,7 +3100,7 @@
             <a:endParaRPr lang="en-US" sz="1100" dirty="0"/>
           </a:p>
           <a:p>
-            <a:pPr indent="0" marL="0">
+            <a:pPr marL="0" indent="0">
               <a:buNone/>
             </a:pPr>
             <a:r>
@@ -3284,7 +3117,7 @@
             <a:endParaRPr lang="en-US" sz="1100" dirty="0"/>
           </a:p>
           <a:p>
-            <a:pPr indent="0" marL="0">
+            <a:pPr marL="0" indent="0">
               <a:buNone/>
             </a:pPr>
             <a:r>
@@ -3301,7 +3134,7 @@
             <a:endParaRPr lang="en-US" sz="1100" dirty="0"/>
           </a:p>
           <a:p>
-            <a:pPr indent="0" marL="0">
+            <a:pPr marL="0" indent="0">
               <a:buNone/>
             </a:pPr>
             <a:r>
@@ -3318,7 +3151,7 @@
             <a:endParaRPr lang="en-US" sz="1100" dirty="0"/>
           </a:p>
           <a:p>
-            <a:pPr indent="0" marL="0">
+            <a:pPr marL="0" indent="0">
               <a:buNone/>
             </a:pPr>
             <a:r>
@@ -3335,7 +3168,7 @@
             <a:endParaRPr lang="en-US" sz="1100" dirty="0"/>
           </a:p>
           <a:p>
-            <a:pPr indent="0" marL="0">
+            <a:pPr marL="0" indent="0">
               <a:buNone/>
             </a:pPr>
             <a:r>
@@ -3372,6 +3205,13 @@
           </a:solidFill>
           <a:ln/>
         </p:spPr>
+        <p:txBody>
+          <a:bodyPr/>
+          <a:lstStyle/>
+          <a:p>
+            <a:endParaRPr lang="en-US"/>
+          </a:p>
+        </p:txBody>
       </p:sp>
       <p:sp>
         <p:nvSpPr>
@@ -3394,7 +3234,7 @@
           <a:bodyPr wrap="square" rtlCol="0" anchor="t"/>
           <a:lstStyle/>
           <a:p>
-            <a:pPr indent="0" marL="0">
+            <a:pPr marL="0" indent="0">
               <a:buNone/>
             </a:pPr>
             <a:r>
@@ -3408,9 +3248,6 @@
               </a:rPr>
               <a:t>Andy's response (Clark, 2016, pp. 206-212): </a:t>
             </a:r>
-            <a:pPr indent="0" marL="0">
-              <a:buNone/>
-            </a:pPr>
             <a:r>
               <a:rPr lang="en-US" sz="1200" dirty="0">
                 <a:solidFill>
@@ -3425,13 +3262,13 @@
             <a:endParaRPr lang="en-US" sz="1200" dirty="0"/>
           </a:p>
           <a:p>
-            <a:pPr indent="0" marL="0">
+            <a:pPr marL="0" indent="0">
               <a:buNone/>
             </a:pPr>
             <a:endParaRPr lang="en-US" sz="1200" dirty="0"/>
           </a:p>
           <a:p>
-            <a:pPr indent="0" marL="0">
+            <a:pPr marL="0" indent="0">
               <a:buNone/>
             </a:pPr>
             <a:r>
@@ -3445,9 +3282,6 @@
               </a:rPr>
               <a:t>Our concern: </a:t>
             </a:r>
-            <a:pPr indent="0" marL="0">
-              <a:buNone/>
-            </a:pPr>
             <a:r>
               <a:rPr lang="en-US" sz="1200" dirty="0">
                 <a:solidFill>
@@ -3484,7 +3318,7 @@
           <a:bodyPr wrap="square" rtlCol="0" anchor="ctr"/>
           <a:lstStyle/>
           <a:p>
-            <a:pPr indent="0" marL="0">
+            <a:pPr marL="0" indent="0">
               <a:buNone/>
             </a:pPr>
             <a:r>
@@ -3518,6 +3352,7 @@
         <a:solidFill>
           <a:srgbClr val="F5F0E8"/>
         </a:solidFill>
+        <a:effectLst/>
       </p:bgPr>
     </p:bg>
     <p:spTree>
@@ -3553,6 +3388,13 @@
           </a:solidFill>
           <a:ln/>
         </p:spPr>
+        <p:txBody>
+          <a:bodyPr/>
+          <a:lstStyle/>
+          <a:p>
+            <a:endParaRPr lang="en-US"/>
+          </a:p>
+        </p:txBody>
       </p:sp>
       <p:sp>
         <p:nvSpPr>
@@ -3575,7 +3417,7 @@
           <a:bodyPr wrap="square" rtlCol="0" anchor="ctr"/>
           <a:lstStyle/>
           <a:p>
-            <a:pPr indent="0" marL="0">
+            <a:pPr marL="0" indent="0">
               <a:buNone/>
             </a:pPr>
             <a:r>
@@ -3614,7 +3456,7 @@
           <a:bodyPr wrap="square" rtlCol="0" anchor="ctr"/>
           <a:lstStyle/>
           <a:p>
-            <a:pPr indent="0" marL="0">
+            <a:pPr marL="0" indent="0">
               <a:buNone/>
             </a:pPr>
             <a:r>
@@ -3631,7 +3473,7 @@
             <a:endParaRPr lang="en-US" sz="2600" dirty="0"/>
           </a:p>
           <a:p>
-            <a:pPr indent="0" marL="0">
+            <a:pPr marL="0" indent="0">
               <a:buNone/>
             </a:pPr>
             <a:r>
@@ -3668,6 +3510,13 @@
           </a:solidFill>
           <a:ln/>
         </p:spPr>
+        <p:txBody>
+          <a:bodyPr/>
+          <a:lstStyle/>
+          <a:p>
+            <a:endParaRPr lang="en-US"/>
+          </a:p>
+        </p:txBody>
       </p:sp>
       <p:sp>
         <p:nvSpPr>
@@ -3688,6 +3537,13 @@
           </a:solidFill>
           <a:ln/>
         </p:spPr>
+        <p:txBody>
+          <a:bodyPr/>
+          <a:lstStyle/>
+          <a:p>
+            <a:endParaRPr lang="en-US"/>
+          </a:p>
+        </p:txBody>
       </p:sp>
       <p:sp>
         <p:nvSpPr>
@@ -3708,6 +3564,13 @@
           </a:solidFill>
           <a:ln/>
         </p:spPr>
+        <p:txBody>
+          <a:bodyPr/>
+          <a:lstStyle/>
+          <a:p>
+            <a:endParaRPr lang="en-US"/>
+          </a:p>
+        </p:txBody>
       </p:sp>
       <p:sp>
         <p:nvSpPr>
@@ -3730,7 +3593,7 @@
           <a:bodyPr wrap="square" rtlCol="0" anchor="ctr"/>
           <a:lstStyle/>
           <a:p>
-            <a:pPr algn="ctr" indent="0" marL="0">
+            <a:pPr marL="0" indent="0" algn="ctr">
               <a:buNone/>
             </a:pPr>
             <a:r>
@@ -3769,7 +3632,7 @@
           <a:bodyPr wrap="square" rtlCol="0" anchor="ctr"/>
           <a:lstStyle/>
           <a:p>
-            <a:pPr algn="ctr" indent="0" marL="0">
+            <a:pPr marL="0" indent="0" algn="ctr">
               <a:buNone/>
             </a:pPr>
             <a:r>
@@ -3806,6 +3669,13 @@
           </a:solidFill>
           <a:ln/>
         </p:spPr>
+        <p:txBody>
+          <a:bodyPr/>
+          <a:lstStyle/>
+          <a:p>
+            <a:endParaRPr lang="en-US"/>
+          </a:p>
+        </p:txBody>
       </p:sp>
       <p:sp>
         <p:nvSpPr>
@@ -3828,7 +3698,7 @@
           <a:bodyPr wrap="square" rtlCol="0" anchor="ctr"/>
           <a:lstStyle/>
           <a:p>
-            <a:pPr indent="0" marL="0">
+            <a:pPr marL="0" indent="0">
               <a:buNone/>
             </a:pPr>
             <a:r>
@@ -3867,7 +3737,7 @@
           <a:bodyPr wrap="square" rtlCol="0" anchor="ctr"/>
           <a:lstStyle/>
           <a:p>
-            <a:pPr algn="ctr" indent="0" marL="0">
+            <a:pPr marL="0" indent="0" algn="ctr">
               <a:buNone/>
             </a:pPr>
             <a:r>
@@ -3906,7 +3776,7 @@
           <a:bodyPr wrap="square" rtlCol="0" anchor="ctr"/>
           <a:lstStyle/>
           <a:p>
-            <a:pPr algn="ctr" indent="0" marL="0">
+            <a:pPr marL="0" indent="0" algn="ctr">
               <a:buNone/>
             </a:pPr>
             <a:r>
@@ -3943,6 +3813,13 @@
           </a:solidFill>
           <a:ln/>
         </p:spPr>
+        <p:txBody>
+          <a:bodyPr/>
+          <a:lstStyle/>
+          <a:p>
+            <a:endParaRPr lang="en-US"/>
+          </a:p>
+        </p:txBody>
       </p:sp>
       <p:sp>
         <p:nvSpPr>
@@ -3965,7 +3842,7 @@
           <a:bodyPr wrap="square" rtlCol="0" anchor="ctr"/>
           <a:lstStyle/>
           <a:p>
-            <a:pPr indent="0" marL="0">
+            <a:pPr marL="0" indent="0">
               <a:buNone/>
             </a:pPr>
             <a:r>
@@ -4004,7 +3881,7 @@
           <a:bodyPr wrap="square" rtlCol="0" anchor="ctr"/>
           <a:lstStyle/>
           <a:p>
-            <a:pPr algn="ctr" indent="0" marL="0">
+            <a:pPr marL="0" indent="0" algn="ctr">
               <a:buNone/>
             </a:pPr>
             <a:r>
@@ -4021,7 +3898,7 @@
             <a:endParaRPr lang="en-US" sz="900" dirty="0"/>
           </a:p>
           <a:p>
-            <a:pPr algn="ctr" indent="0" marL="0">
+            <a:pPr marL="0" indent="0" algn="ctr">
               <a:buNone/>
             </a:pPr>
             <a:r>
@@ -4060,7 +3937,7 @@
           <a:bodyPr wrap="square" rtlCol="0" anchor="ctr"/>
           <a:lstStyle/>
           <a:p>
-            <a:pPr algn="ctr" indent="0" marL="0">
+            <a:pPr marL="0" indent="0" algn="ctr">
               <a:buNone/>
             </a:pPr>
             <a:r>
@@ -4077,7 +3954,7 @@
             <a:endParaRPr lang="en-US" sz="900" dirty="0"/>
           </a:p>
           <a:p>
-            <a:pPr algn="ctr" indent="0" marL="0">
+            <a:pPr marL="0" indent="0" algn="ctr">
               <a:buNone/>
             </a:pPr>
             <a:r>
@@ -4114,6 +3991,13 @@
           </a:solidFill>
           <a:ln/>
         </p:spPr>
+        <p:txBody>
+          <a:bodyPr/>
+          <a:lstStyle/>
+          <a:p>
+            <a:endParaRPr lang="en-US"/>
+          </a:p>
+        </p:txBody>
       </p:sp>
       <p:sp>
         <p:nvSpPr>
@@ -4136,7 +4020,7 @@
           <a:bodyPr wrap="square" rtlCol="0" anchor="ctr"/>
           <a:lstStyle/>
           <a:p>
-            <a:pPr indent="0" marL="0">
+            <a:pPr marL="0" indent="0">
               <a:buNone/>
             </a:pPr>
             <a:r>
@@ -4175,7 +4059,7 @@
           <a:bodyPr wrap="square" rtlCol="0" anchor="ctr"/>
           <a:lstStyle/>
           <a:p>
-            <a:pPr algn="ctr" indent="0" marL="0">
+            <a:pPr marL="0" indent="0" algn="ctr">
               <a:buNone/>
             </a:pPr>
             <a:r>
@@ -4192,7 +4076,7 @@
             <a:endParaRPr lang="en-US" sz="900" dirty="0"/>
           </a:p>
           <a:p>
-            <a:pPr algn="ctr" indent="0" marL="0">
+            <a:pPr marL="0" indent="0" algn="ctr">
               <a:buNone/>
             </a:pPr>
             <a:r>
@@ -4231,7 +4115,7 @@
           <a:bodyPr wrap="square" rtlCol="0" anchor="ctr"/>
           <a:lstStyle/>
           <a:p>
-            <a:pPr algn="ctr" indent="0" marL="0">
+            <a:pPr marL="0" indent="0" algn="ctr">
               <a:buNone/>
             </a:pPr>
             <a:r>
@@ -4248,7 +4132,7 @@
             <a:endParaRPr lang="en-US" sz="900" dirty="0"/>
           </a:p>
           <a:p>
-            <a:pPr algn="ctr" indent="0" marL="0">
+            <a:pPr marL="0" indent="0" algn="ctr">
               <a:buNone/>
             </a:pPr>
             <a:r>
@@ -4285,6 +4169,13 @@
           </a:solidFill>
           <a:ln/>
         </p:spPr>
+        <p:txBody>
+          <a:bodyPr/>
+          <a:lstStyle/>
+          <a:p>
+            <a:endParaRPr lang="en-US"/>
+          </a:p>
+        </p:txBody>
       </p:sp>
       <p:sp>
         <p:nvSpPr>
@@ -4307,7 +4198,7 @@
           <a:bodyPr wrap="square" rtlCol="0" anchor="ctr"/>
           <a:lstStyle/>
           <a:p>
-            <a:pPr indent="0" marL="0">
+            <a:pPr marL="0" indent="0">
               <a:buNone/>
             </a:pPr>
             <a:r>
@@ -4346,7 +4237,7 @@
           <a:bodyPr wrap="square" rtlCol="0" anchor="ctr"/>
           <a:lstStyle/>
           <a:p>
-            <a:pPr algn="ctr" indent="0" marL="0">
+            <a:pPr marL="0" indent="0" algn="ctr">
               <a:buNone/>
             </a:pPr>
             <a:r>
@@ -4363,7 +4254,7 @@
             <a:endParaRPr lang="en-US" sz="900" dirty="0"/>
           </a:p>
           <a:p>
-            <a:pPr algn="ctr" indent="0" marL="0">
+            <a:pPr marL="0" indent="0" algn="ctr">
               <a:buNone/>
             </a:pPr>
             <a:r>
@@ -4402,7 +4293,7 @@
           <a:bodyPr wrap="square" rtlCol="0" anchor="ctr"/>
           <a:lstStyle/>
           <a:p>
-            <a:pPr algn="ctr" indent="0" marL="0">
+            <a:pPr marL="0" indent="0" algn="ctr">
               <a:buNone/>
             </a:pPr>
             <a:r>
@@ -4419,7 +4310,7 @@
             <a:endParaRPr lang="en-US" sz="900" dirty="0"/>
           </a:p>
           <a:p>
-            <a:pPr algn="ctr" indent="0" marL="0">
+            <a:pPr marL="0" indent="0" algn="ctr">
               <a:buNone/>
             </a:pPr>
             <a:r>
@@ -4456,6 +4347,13 @@
           </a:solidFill>
           <a:ln/>
         </p:spPr>
+        <p:txBody>
+          <a:bodyPr/>
+          <a:lstStyle/>
+          <a:p>
+            <a:endParaRPr lang="en-US"/>
+          </a:p>
+        </p:txBody>
       </p:sp>
       <p:sp>
         <p:nvSpPr>
@@ -4478,7 +4376,7 @@
           <a:bodyPr wrap="square" rtlCol="0" anchor="ctr"/>
           <a:lstStyle/>
           <a:p>
-            <a:pPr indent="0" marL="0">
+            <a:pPr marL="0" indent="0">
               <a:buNone/>
             </a:pPr>
             <a:r>
@@ -4517,7 +4415,7 @@
           <a:bodyPr wrap="square" rtlCol="0" anchor="ctr"/>
           <a:lstStyle/>
           <a:p>
-            <a:pPr algn="ctr" indent="0" marL="0">
+            <a:pPr marL="0" indent="0" algn="ctr">
               <a:buNone/>
             </a:pPr>
             <a:r>
@@ -4534,7 +4432,7 @@
             <a:endParaRPr lang="en-US" sz="900" dirty="0"/>
           </a:p>
           <a:p>
-            <a:pPr algn="ctr" indent="0" marL="0">
+            <a:pPr marL="0" indent="0" algn="ctr">
               <a:buNone/>
             </a:pPr>
             <a:r>
@@ -4573,7 +4471,7 @@
           <a:bodyPr wrap="square" rtlCol="0" anchor="ctr"/>
           <a:lstStyle/>
           <a:p>
-            <a:pPr algn="ctr" indent="0" marL="0">
+            <a:pPr marL="0" indent="0" algn="ctr">
               <a:buNone/>
             </a:pPr>
             <a:r>
@@ -4590,7 +4488,7 @@
             <a:endParaRPr lang="en-US" sz="900" dirty="0"/>
           </a:p>
           <a:p>
-            <a:pPr algn="ctr" indent="0" marL="0">
+            <a:pPr marL="0" indent="0" algn="ctr">
               <a:buNone/>
             </a:pPr>
             <a:r>
@@ -4627,6 +4525,13 @@
           </a:solidFill>
           <a:ln/>
         </p:spPr>
+        <p:txBody>
+          <a:bodyPr/>
+          <a:lstStyle/>
+          <a:p>
+            <a:endParaRPr lang="en-US"/>
+          </a:p>
+        </p:txBody>
       </p:sp>
       <p:sp>
         <p:nvSpPr>
@@ -4649,7 +4554,7 @@
           <a:bodyPr wrap="square" rtlCol="0" anchor="ctr"/>
           <a:lstStyle/>
           <a:p>
-            <a:pPr indent="0" marL="0">
+            <a:pPr marL="0" indent="0">
               <a:buNone/>
             </a:pPr>
             <a:r>
@@ -4688,7 +4593,7 @@
           <a:bodyPr wrap="square" rtlCol="0" anchor="ctr"/>
           <a:lstStyle/>
           <a:p>
-            <a:pPr algn="ctr" indent="0" marL="0">
+            <a:pPr marL="0" indent="0" algn="ctr">
               <a:buNone/>
             </a:pPr>
             <a:r>
@@ -4705,7 +4610,7 @@
             <a:endParaRPr lang="en-US" sz="900" dirty="0"/>
           </a:p>
           <a:p>
-            <a:pPr algn="ctr" indent="0" marL="0">
+            <a:pPr marL="0" indent="0" algn="ctr">
               <a:buNone/>
             </a:pPr>
             <a:r>
@@ -4744,7 +4649,7 @@
           <a:bodyPr wrap="square" rtlCol="0" anchor="ctr"/>
           <a:lstStyle/>
           <a:p>
-            <a:pPr algn="ctr" indent="0" marL="0">
+            <a:pPr marL="0" indent="0" algn="ctr">
               <a:buNone/>
             </a:pPr>
             <a:r>
@@ -4761,7 +4666,7 @@
             <a:endParaRPr lang="en-US" sz="900" dirty="0"/>
           </a:p>
           <a:p>
-            <a:pPr algn="ctr" indent="0" marL="0">
+            <a:pPr marL="0" indent="0" algn="ctr">
               <a:buNone/>
             </a:pPr>
             <a:r>
@@ -4798,6 +4703,13 @@
           </a:solidFill>
           <a:ln/>
         </p:spPr>
+        <p:txBody>
+          <a:bodyPr/>
+          <a:lstStyle/>
+          <a:p>
+            <a:endParaRPr lang="en-US"/>
+          </a:p>
+        </p:txBody>
       </p:sp>
       <p:sp>
         <p:nvSpPr>
@@ -4820,7 +4732,7 @@
           <a:bodyPr wrap="square" rtlCol="0" anchor="ctr"/>
           <a:lstStyle/>
           <a:p>
-            <a:pPr indent="0" marL="0">
+            <a:pPr marL="0" indent="0">
               <a:buNone/>
             </a:pPr>
             <a:r>
@@ -4859,7 +4771,7 @@
           <a:bodyPr wrap="square" rtlCol="0" anchor="ctr"/>
           <a:lstStyle/>
           <a:p>
-            <a:pPr algn="ctr" indent="0" marL="0">
+            <a:pPr marL="0" indent="0" algn="ctr">
               <a:buNone/>
             </a:pPr>
             <a:r>
@@ -4876,7 +4788,7 @@
             <a:endParaRPr lang="en-US" sz="900" dirty="0"/>
           </a:p>
           <a:p>
-            <a:pPr algn="ctr" indent="0" marL="0">
+            <a:pPr marL="0" indent="0" algn="ctr">
               <a:buNone/>
             </a:pPr>
             <a:r>
@@ -4915,7 +4827,7 @@
           <a:bodyPr wrap="square" rtlCol="0" anchor="ctr"/>
           <a:lstStyle/>
           <a:p>
-            <a:pPr algn="ctr" indent="0" marL="0">
+            <a:pPr marL="0" indent="0" algn="ctr">
               <a:buNone/>
             </a:pPr>
             <a:r>
@@ -4932,7 +4844,7 @@
             <a:endParaRPr lang="en-US" sz="900" dirty="0"/>
           </a:p>
           <a:p>
-            <a:pPr algn="ctr" indent="0" marL="0">
+            <a:pPr marL="0" indent="0" algn="ctr">
               <a:buNone/>
             </a:pPr>
             <a:r>
@@ -4971,7 +4883,7 @@
           <a:bodyPr wrap="square" rtlCol="0" anchor="ctr"/>
           <a:lstStyle/>
           <a:p>
-            <a:pPr indent="0" marL="0">
+            <a:pPr marL="0" indent="0">
               <a:buNone/>
             </a:pPr>
             <a:r>
@@ -4988,7 +4900,7 @@
             <a:endParaRPr lang="en-US" sz="1100" dirty="0"/>
           </a:p>
           <a:p>
-            <a:pPr indent="0" marL="0">
+            <a:pPr marL="0" indent="0">
               <a:buNone/>
             </a:pPr>
             <a:r>
@@ -5027,7 +4939,7 @@
           <a:bodyPr wrap="square" rtlCol="0" anchor="ctr"/>
           <a:lstStyle/>
           <a:p>
-            <a:pPr indent="0" marL="0">
+            <a:pPr marL="0" indent="0">
               <a:buNone/>
             </a:pPr>
             <a:r>
@@ -5061,6 +4973,7 @@
         <a:solidFill>
           <a:srgbClr val="F5F0E8"/>
         </a:solidFill>
+        <a:effectLst/>
       </p:bgPr>
     </p:bg>
     <p:spTree>
@@ -5096,6 +5009,13 @@
           </a:solidFill>
           <a:ln/>
         </p:spPr>
+        <p:txBody>
+          <a:bodyPr/>
+          <a:lstStyle/>
+          <a:p>
+            <a:endParaRPr lang="en-US"/>
+          </a:p>
+        </p:txBody>
       </p:sp>
       <p:sp>
         <p:nvSpPr>
@@ -5118,7 +5038,7 @@
           <a:bodyPr wrap="square" rtlCol="0" anchor="ctr"/>
           <a:lstStyle/>
           <a:p>
-            <a:pPr indent="0" marL="0">
+            <a:pPr marL="0" indent="0">
               <a:buNone/>
             </a:pPr>
             <a:r>
@@ -5157,7 +5077,7 @@
           <a:bodyPr wrap="square" rtlCol="0" anchor="ctr"/>
           <a:lstStyle/>
           <a:p>
-            <a:pPr indent="0" marL="0">
+            <a:pPr marL="0" indent="0">
               <a:buNone/>
             </a:pPr>
             <a:r>
@@ -5174,7 +5094,7 @@
             <a:endParaRPr lang="en-US" sz="2800" dirty="0"/>
           </a:p>
           <a:p>
-            <a:pPr indent="0" marL="0">
+            <a:pPr marL="0" indent="0">
               <a:buNone/>
             </a:pPr>
             <a:r>
@@ -5213,7 +5133,7 @@
           <a:bodyPr wrap="square" rtlCol="0" anchor="ctr"/>
           <a:lstStyle/>
           <a:p>
-            <a:pPr indent="0" marL="0">
+            <a:pPr marL="0" indent="0">
               <a:buNone/>
             </a:pPr>
             <a:r>
@@ -5230,13 +5150,13 @@
             <a:endParaRPr lang="en-US" sz="1500" dirty="0"/>
           </a:p>
           <a:p>
-            <a:pPr indent="0" marL="0">
+            <a:pPr marL="0" indent="0">
               <a:buNone/>
             </a:pPr>
             <a:endParaRPr lang="en-US" sz="1500" dirty="0"/>
           </a:p>
           <a:p>
-            <a:pPr indent="0" marL="0">
+            <a:pPr marL="0" indent="0">
               <a:buNone/>
             </a:pPr>
             <a:r>
@@ -5273,6 +5193,13 @@
           </a:solidFill>
           <a:ln/>
         </p:spPr>
+        <p:txBody>
+          <a:bodyPr/>
+          <a:lstStyle/>
+          <a:p>
+            <a:endParaRPr lang="en-US"/>
+          </a:p>
+        </p:txBody>
       </p:sp>
       <p:sp>
         <p:nvSpPr>
@@ -5295,7 +5222,7 @@
           <a:bodyPr wrap="square" rtlCol="0" anchor="ctr"/>
           <a:lstStyle/>
           <a:p>
-            <a:pPr indent="0" marL="0">
+            <a:pPr marL="0" indent="0">
               <a:buNone/>
             </a:pPr>
             <a:r>
@@ -5334,7 +5261,7 @@
           <a:bodyPr wrap="square" rtlCol="0" anchor="t"/>
           <a:lstStyle/>
           <a:p>
-            <a:pPr indent="0" marL="0">
+            <a:pPr marL="0" indent="0">
               <a:buNone/>
             </a:pPr>
             <a:r>
@@ -5351,7 +5278,7 @@
             <a:endParaRPr lang="en-US" sz="1200" dirty="0"/>
           </a:p>
           <a:p>
-            <a:pPr indent="0" marL="0">
+            <a:pPr marL="0" indent="0">
               <a:buNone/>
             </a:pPr>
             <a:r>
@@ -5368,7 +5295,7 @@
             <a:endParaRPr lang="en-US" sz="1200" dirty="0"/>
           </a:p>
           <a:p>
-            <a:pPr indent="0" marL="0">
+            <a:pPr marL="0" indent="0">
               <a:buNone/>
             </a:pPr>
             <a:r>
@@ -5385,7 +5312,7 @@
             <a:endParaRPr lang="en-US" sz="1200" dirty="0"/>
           </a:p>
           <a:p>
-            <a:pPr indent="0" marL="0">
+            <a:pPr marL="0" indent="0">
               <a:buNone/>
             </a:pPr>
             <a:r>
@@ -5422,6 +5349,13 @@
           </a:solidFill>
           <a:ln/>
         </p:spPr>
+        <p:txBody>
+          <a:bodyPr/>
+          <a:lstStyle/>
+          <a:p>
+            <a:endParaRPr lang="en-US"/>
+          </a:p>
+        </p:txBody>
       </p:sp>
       <p:sp>
         <p:nvSpPr>
@@ -5444,7 +5378,7 @@
           <a:bodyPr wrap="square" rtlCol="0" anchor="ctr"/>
           <a:lstStyle/>
           <a:p>
-            <a:pPr indent="0" marL="0">
+            <a:pPr marL="0" indent="0">
               <a:buNone/>
             </a:pPr>
             <a:r>
@@ -5483,7 +5417,7 @@
           <a:bodyPr wrap="square" rtlCol="0" anchor="t"/>
           <a:lstStyle/>
           <a:p>
-            <a:pPr indent="0" marL="0">
+            <a:pPr marL="0" indent="0">
               <a:buNone/>
             </a:pPr>
             <a:r>
@@ -5500,7 +5434,7 @@
             <a:endParaRPr lang="en-US" sz="1200" dirty="0"/>
           </a:p>
           <a:p>
-            <a:pPr indent="0" marL="0">
+            <a:pPr marL="0" indent="0">
               <a:buNone/>
             </a:pPr>
             <a:r>
@@ -5517,7 +5451,7 @@
             <a:endParaRPr lang="en-US" sz="1200" dirty="0"/>
           </a:p>
           <a:p>
-            <a:pPr indent="0" marL="0">
+            <a:pPr marL="0" indent="0">
               <a:buNone/>
             </a:pPr>
             <a:r>
@@ -5534,7 +5468,7 @@
             <a:endParaRPr lang="en-US" sz="1200" dirty="0"/>
           </a:p>
           <a:p>
-            <a:pPr indent="0" marL="0">
+            <a:pPr marL="0" indent="0">
               <a:buNone/>
             </a:pPr>
             <a:r>
@@ -5571,6 +5505,13 @@
           </a:solidFill>
           <a:ln/>
         </p:spPr>
+        <p:txBody>
+          <a:bodyPr/>
+          <a:lstStyle/>
+          <a:p>
+            <a:endParaRPr lang="en-US"/>
+          </a:p>
+        </p:txBody>
       </p:sp>
       <p:sp>
         <p:nvSpPr>
@@ -5593,7 +5534,7 @@
           <a:bodyPr wrap="square" rtlCol="0" anchor="ctr"/>
           <a:lstStyle/>
           <a:p>
-            <a:pPr indent="0" marL="0">
+            <a:pPr marL="0" indent="0">
               <a:buNone/>
             </a:pPr>
             <a:r>
@@ -5607,9 +5548,6 @@
               </a:rPr>
               <a:t>Critical point: </a:t>
             </a:r>
-            <a:pPr indent="0" marL="0">
-              <a:buNone/>
-            </a:pPr>
             <a:r>
               <a:rPr lang="en-US" sz="1200" dirty="0">
                 <a:solidFill>
@@ -5646,7 +5584,7 @@
           <a:bodyPr wrap="square" rtlCol="0" anchor="ctr"/>
           <a:lstStyle/>
           <a:p>
-            <a:pPr indent="0" marL="0">
+            <a:pPr marL="0" indent="0">
               <a:buNone/>
             </a:pPr>
             <a:r>
@@ -5680,6 +5618,7 @@
         <a:solidFill>
           <a:srgbClr val="F5F0E8"/>
         </a:solidFill>
+        <a:effectLst/>
       </p:bgPr>
     </p:bg>
     <p:spTree>
@@ -5715,6 +5654,13 @@
           </a:solidFill>
           <a:ln/>
         </p:spPr>
+        <p:txBody>
+          <a:bodyPr/>
+          <a:lstStyle/>
+          <a:p>
+            <a:endParaRPr lang="en-US"/>
+          </a:p>
+        </p:txBody>
       </p:sp>
       <p:sp>
         <p:nvSpPr>
@@ -5737,7 +5683,7 @@
           <a:bodyPr wrap="square" rtlCol="0" anchor="ctr"/>
           <a:lstStyle/>
           <a:p>
-            <a:pPr indent="0" marL="0">
+            <a:pPr marL="0" indent="0">
               <a:buNone/>
             </a:pPr>
             <a:r>
@@ -5776,7 +5722,7 @@
           <a:bodyPr wrap="square" rtlCol="0" anchor="ctr"/>
           <a:lstStyle/>
           <a:p>
-            <a:pPr indent="0" marL="0">
+            <a:pPr marL="0" indent="0">
               <a:buNone/>
             </a:pPr>
             <a:r>
@@ -5793,7 +5739,7 @@
             <a:endParaRPr lang="en-US" sz="2600" dirty="0"/>
           </a:p>
           <a:p>
-            <a:pPr indent="0" marL="0">
+            <a:pPr marL="0" indent="0">
               <a:buNone/>
             </a:pPr>
             <a:r>
@@ -5830,6 +5776,13 @@
           </a:solidFill>
           <a:ln/>
         </p:spPr>
+        <p:txBody>
+          <a:bodyPr/>
+          <a:lstStyle/>
+          <a:p>
+            <a:endParaRPr lang="en-US"/>
+          </a:p>
+        </p:txBody>
       </p:sp>
       <p:sp>
         <p:nvSpPr>
@@ -5852,7 +5805,7 @@
           <a:bodyPr wrap="square" rtlCol="0" anchor="ctr"/>
           <a:lstStyle/>
           <a:p>
-            <a:pPr indent="0" marL="0">
+            <a:pPr marL="0" indent="0">
               <a:buNone/>
             </a:pPr>
             <a:r>
@@ -5891,7 +5844,7 @@
           <a:bodyPr wrap="square" rtlCol="0" anchor="ctr"/>
           <a:lstStyle/>
           <a:p>
-            <a:pPr indent="0" marL="0">
+            <a:pPr marL="0" indent="0">
               <a:buNone/>
             </a:pPr>
             <a:r>
@@ -5928,6 +5881,13 @@
           </a:solidFill>
           <a:ln/>
         </p:spPr>
+        <p:txBody>
+          <a:bodyPr/>
+          <a:lstStyle/>
+          <a:p>
+            <a:endParaRPr lang="en-US"/>
+          </a:p>
+        </p:txBody>
       </p:sp>
       <p:sp>
         <p:nvSpPr>
@@ -5950,7 +5910,7 @@
           <a:bodyPr wrap="square" rtlCol="0" anchor="ctr"/>
           <a:lstStyle/>
           <a:p>
-            <a:pPr indent="0" marL="0">
+            <a:pPr marL="0" indent="0">
               <a:buNone/>
             </a:pPr>
             <a:r>
@@ -5967,7 +5927,7 @@
             <a:endParaRPr lang="en-US" sz="1100" dirty="0"/>
           </a:p>
           <a:p>
-            <a:pPr indent="0" marL="0">
+            <a:pPr marL="0" indent="0">
               <a:buNone/>
             </a:pPr>
             <a:r>
@@ -6006,7 +5966,7 @@
           <a:bodyPr wrap="square" rtlCol="0" anchor="ctr"/>
           <a:lstStyle/>
           <a:p>
-            <a:pPr indent="0" marL="0">
+            <a:pPr marL="0" indent="0">
               <a:buNone/>
             </a:pPr>
             <a:r>
@@ -6043,6 +6003,13 @@
           </a:solidFill>
           <a:ln/>
         </p:spPr>
+        <p:txBody>
+          <a:bodyPr/>
+          <a:lstStyle/>
+          <a:p>
+            <a:endParaRPr lang="en-US"/>
+          </a:p>
+        </p:txBody>
       </p:sp>
       <p:sp>
         <p:nvSpPr>
@@ -6065,7 +6032,7 @@
           <a:bodyPr wrap="square" rtlCol="0" anchor="ctr"/>
           <a:lstStyle/>
           <a:p>
-            <a:pPr indent="0" marL="0">
+            <a:pPr marL="0" indent="0">
               <a:buNone/>
             </a:pPr>
             <a:r>
@@ -6082,7 +6049,7 @@
             <a:endParaRPr lang="en-US" sz="1100" dirty="0"/>
           </a:p>
           <a:p>
-            <a:pPr indent="0" marL="0">
+            <a:pPr marL="0" indent="0">
               <a:buNone/>
             </a:pPr>
             <a:r>
@@ -6121,7 +6088,7 @@
           <a:bodyPr wrap="square" rtlCol="0" anchor="ctr"/>
           <a:lstStyle/>
           <a:p>
-            <a:pPr indent="0" marL="0">
+            <a:pPr marL="0" indent="0">
               <a:buNone/>
             </a:pPr>
             <a:r>
@@ -6158,6 +6125,13 @@
           </a:solidFill>
           <a:ln/>
         </p:spPr>
+        <p:txBody>
+          <a:bodyPr/>
+          <a:lstStyle/>
+          <a:p>
+            <a:endParaRPr lang="en-US"/>
+          </a:p>
+        </p:txBody>
       </p:sp>
       <p:sp>
         <p:nvSpPr>
@@ -6180,7 +6154,7 @@
           <a:bodyPr wrap="square" rtlCol="0" anchor="ctr"/>
           <a:lstStyle/>
           <a:p>
-            <a:pPr indent="0" marL="0">
+            <a:pPr marL="0" indent="0">
               <a:buNone/>
             </a:pPr>
             <a:r>
@@ -6197,7 +6171,7 @@
             <a:endParaRPr lang="en-US" sz="1100" dirty="0"/>
           </a:p>
           <a:p>
-            <a:pPr indent="0" marL="0">
+            <a:pPr marL="0" indent="0">
               <a:buNone/>
             </a:pPr>
             <a:r>
@@ -6236,7 +6210,7 @@
           <a:bodyPr wrap="square" rtlCol="0" anchor="ctr"/>
           <a:lstStyle/>
           <a:p>
-            <a:pPr indent="0" marL="0">
+            <a:pPr marL="0" indent="0">
               <a:buNone/>
             </a:pPr>
             <a:r>
@@ -6275,7 +6249,7 @@
           <a:bodyPr wrap="square" rtlCol="0" anchor="ctr"/>
           <a:lstStyle/>
           <a:p>
-            <a:pPr indent="0" marL="0">
+            <a:pPr marL="0" indent="0">
               <a:buNone/>
             </a:pPr>
             <a:r>
@@ -6314,7 +6288,7 @@
           <a:bodyPr wrap="square" rtlCol="0" anchor="ctr"/>
           <a:lstStyle/>
           <a:p>
-            <a:pPr indent="0" marL="0">
+            <a:pPr marL="0" indent="0">
               <a:buNone/>
             </a:pPr>
             <a:r>
@@ -6348,6 +6322,7 @@
         <a:solidFill>
           <a:srgbClr val="F5F0E8"/>
         </a:solidFill>
+        <a:effectLst/>
       </p:bgPr>
     </p:bg>
     <p:spTree>
@@ -6383,6 +6358,13 @@
           </a:solidFill>
           <a:ln/>
         </p:spPr>
+        <p:txBody>
+          <a:bodyPr/>
+          <a:lstStyle/>
+          <a:p>
+            <a:endParaRPr lang="en-US"/>
+          </a:p>
+        </p:txBody>
       </p:sp>
       <p:sp>
         <p:nvSpPr>
@@ -6405,7 +6387,7 @@
           <a:bodyPr wrap="square" rtlCol="0" anchor="ctr"/>
           <a:lstStyle/>
           <a:p>
-            <a:pPr indent="0" marL="0">
+            <a:pPr marL="0" indent="0">
               <a:buNone/>
             </a:pPr>
             <a:r>
@@ -6444,7 +6426,7 @@
           <a:bodyPr wrap="square" rtlCol="0" anchor="ctr"/>
           <a:lstStyle/>
           <a:p>
-            <a:pPr indent="0" marL="0">
+            <a:pPr marL="0" indent="0">
               <a:buNone/>
             </a:pPr>
             <a:r>
@@ -6461,7 +6443,7 @@
             <a:endParaRPr lang="en-US" sz="2600" dirty="0"/>
           </a:p>
           <a:p>
-            <a:pPr indent="0" marL="0">
+            <a:pPr marL="0" indent="0">
               <a:buNone/>
             </a:pPr>
             <a:r>
@@ -6498,6 +6480,13 @@
           </a:solidFill>
           <a:ln/>
         </p:spPr>
+        <p:txBody>
+          <a:bodyPr/>
+          <a:lstStyle/>
+          <a:p>
+            <a:endParaRPr lang="en-US"/>
+          </a:p>
+        </p:txBody>
       </p:sp>
       <p:sp>
         <p:nvSpPr>
@@ -6520,7 +6509,7 @@
           <a:bodyPr wrap="square" rtlCol="0" anchor="b"/>
           <a:lstStyle/>
           <a:p>
-            <a:pPr algn="ctr" indent="0" marL="0">
+            <a:pPr marL="0" indent="0" algn="ctr">
               <a:buNone/>
             </a:pPr>
             <a:r>
@@ -6559,7 +6548,7 @@
           <a:bodyPr wrap="square" rtlCol="0" anchor="t"/>
           <a:lstStyle/>
           <a:p>
-            <a:pPr algn="ctr" indent="0" marL="0">
+            <a:pPr marL="0" indent="0" algn="ctr">
               <a:buNone/>
             </a:pPr>
             <a:r>
@@ -6598,7 +6587,7 @@
           <a:bodyPr wrap="square" rtlCol="0" anchor="ctr"/>
           <a:lstStyle/>
           <a:p>
-            <a:pPr indent="0" marL="0">
+            <a:pPr marL="0" indent="0">
               <a:buNone/>
             </a:pPr>
             <a:r>
@@ -6637,7 +6626,7 @@
           <a:bodyPr wrap="square" rtlCol="0" anchor="ctr"/>
           <a:lstStyle/>
           <a:p>
-            <a:pPr indent="0" marL="0">
+            <a:pPr marL="0" indent="0">
               <a:buNone/>
             </a:pPr>
             <a:r>
@@ -6654,7 +6643,7 @@
             <a:endParaRPr lang="en-US" sz="1000" dirty="0"/>
           </a:p>
           <a:p>
-            <a:pPr indent="0" marL="0">
+            <a:pPr marL="0" indent="0">
               <a:buNone/>
             </a:pPr>
             <a:r>
@@ -6691,6 +6680,13 @@
           </a:solidFill>
           <a:ln/>
         </p:spPr>
+        <p:txBody>
+          <a:bodyPr/>
+          <a:lstStyle/>
+          <a:p>
+            <a:endParaRPr lang="en-US"/>
+          </a:p>
+        </p:txBody>
       </p:sp>
       <p:sp>
         <p:nvSpPr>
@@ -6713,7 +6709,7 @@
           <a:bodyPr wrap="square" rtlCol="0" anchor="b"/>
           <a:lstStyle/>
           <a:p>
-            <a:pPr algn="ctr" indent="0" marL="0">
+            <a:pPr marL="0" indent="0" algn="ctr">
               <a:buNone/>
             </a:pPr>
             <a:r>
@@ -6752,7 +6748,7 @@
           <a:bodyPr wrap="square" rtlCol="0" anchor="t"/>
           <a:lstStyle/>
           <a:p>
-            <a:pPr algn="ctr" indent="0" marL="0">
+            <a:pPr marL="0" indent="0" algn="ctr">
               <a:buNone/>
             </a:pPr>
             <a:r>
@@ -6791,7 +6787,7 @@
           <a:bodyPr wrap="square" rtlCol="0" anchor="ctr"/>
           <a:lstStyle/>
           <a:p>
-            <a:pPr indent="0" marL="0">
+            <a:pPr marL="0" indent="0">
               <a:buNone/>
             </a:pPr>
             <a:r>
@@ -6830,7 +6826,7 @@
           <a:bodyPr wrap="square" rtlCol="0" anchor="ctr"/>
           <a:lstStyle/>
           <a:p>
-            <a:pPr indent="0" marL="0">
+            <a:pPr marL="0" indent="0">
               <a:buNone/>
             </a:pPr>
             <a:r>
@@ -6847,7 +6843,7 @@
             <a:endParaRPr lang="en-US" sz="1000" dirty="0"/>
           </a:p>
           <a:p>
-            <a:pPr indent="0" marL="0">
+            <a:pPr marL="0" indent="0">
               <a:buNone/>
             </a:pPr>
             <a:r>
@@ -6884,6 +6880,13 @@
           </a:solidFill>
           <a:ln/>
         </p:spPr>
+        <p:txBody>
+          <a:bodyPr/>
+          <a:lstStyle/>
+          <a:p>
+            <a:endParaRPr lang="en-US"/>
+          </a:p>
+        </p:txBody>
       </p:sp>
       <p:sp>
         <p:nvSpPr>
@@ -6906,7 +6909,7 @@
           <a:bodyPr wrap="square" rtlCol="0" anchor="b"/>
           <a:lstStyle/>
           <a:p>
-            <a:pPr algn="ctr" indent="0" marL="0">
+            <a:pPr marL="0" indent="0" algn="ctr">
               <a:buNone/>
             </a:pPr>
             <a:r>
@@ -6945,7 +6948,7 @@
           <a:bodyPr wrap="square" rtlCol="0" anchor="t"/>
           <a:lstStyle/>
           <a:p>
-            <a:pPr algn="ctr" indent="0" marL="0">
+            <a:pPr marL="0" indent="0" algn="ctr">
               <a:buNone/>
             </a:pPr>
             <a:r>
@@ -6984,7 +6987,7 @@
           <a:bodyPr wrap="square" rtlCol="0" anchor="ctr"/>
           <a:lstStyle/>
           <a:p>
-            <a:pPr indent="0" marL="0">
+            <a:pPr marL="0" indent="0">
               <a:buNone/>
             </a:pPr>
             <a:r>
@@ -7023,7 +7026,7 @@
           <a:bodyPr wrap="square" rtlCol="0" anchor="ctr"/>
           <a:lstStyle/>
           <a:p>
-            <a:pPr indent="0" marL="0">
+            <a:pPr marL="0" indent="0">
               <a:buNone/>
             </a:pPr>
             <a:r>
@@ -7040,7 +7043,7 @@
             <a:endParaRPr lang="en-US" sz="1000" dirty="0"/>
           </a:p>
           <a:p>
-            <a:pPr indent="0" marL="0">
+            <a:pPr marL="0" indent="0">
               <a:buNone/>
             </a:pPr>
             <a:r>
@@ -7079,7 +7082,7 @@
           <a:bodyPr wrap="square" rtlCol="0" anchor="ctr"/>
           <a:lstStyle/>
           <a:p>
-            <a:pPr indent="0" marL="0">
+            <a:pPr marL="0" indent="0">
               <a:buNone/>
             </a:pPr>
             <a:r>
@@ -7118,7 +7121,7 @@
           <a:bodyPr wrap="square" rtlCol="0" anchor="ctr"/>
           <a:lstStyle/>
           <a:p>
-            <a:pPr indent="0" marL="0">
+            <a:pPr marL="0" indent="0">
               <a:buNone/>
             </a:pPr>
             <a:r>
@@ -7152,6 +7155,7 @@
         <a:solidFill>
           <a:srgbClr val="F5F0E8"/>
         </a:solidFill>
+        <a:effectLst/>
       </p:bgPr>
     </p:bg>
     <p:spTree>
@@ -7187,6 +7191,13 @@
           </a:solidFill>
           <a:ln/>
         </p:spPr>
+        <p:txBody>
+          <a:bodyPr/>
+          <a:lstStyle/>
+          <a:p>
+            <a:endParaRPr lang="en-US"/>
+          </a:p>
+        </p:txBody>
       </p:sp>
       <p:sp>
         <p:nvSpPr>
@@ -7209,7 +7220,7 @@
           <a:bodyPr wrap="square" rtlCol="0" anchor="ctr"/>
           <a:lstStyle/>
           <a:p>
-            <a:pPr indent="0" marL="0">
+            <a:pPr marL="0" indent="0">
               <a:buNone/>
             </a:pPr>
             <a:r>
@@ -7248,7 +7259,7 @@
           <a:bodyPr wrap="square" rtlCol="0" anchor="ctr"/>
           <a:lstStyle/>
           <a:p>
-            <a:pPr indent="0" marL="0">
+            <a:pPr marL="0" indent="0">
               <a:buNone/>
             </a:pPr>
             <a:r>
@@ -7265,7 +7276,7 @@
             <a:endParaRPr lang="en-US" sz="2600" dirty="0"/>
           </a:p>
           <a:p>
-            <a:pPr indent="0" marL="0">
+            <a:pPr marL="0" indent="0">
               <a:buNone/>
             </a:pPr>
             <a:r>
@@ -7302,6 +7313,13 @@
           </a:solidFill>
           <a:ln/>
         </p:spPr>
+        <p:txBody>
+          <a:bodyPr/>
+          <a:lstStyle/>
+          <a:p>
+            <a:endParaRPr lang="en-US"/>
+          </a:p>
+        </p:txBody>
       </p:sp>
       <p:sp>
         <p:nvSpPr>
@@ -7324,7 +7342,7 @@
           <a:bodyPr wrap="square" rtlCol="0" anchor="ctr"/>
           <a:lstStyle/>
           <a:p>
-            <a:pPr indent="0" marL="0">
+            <a:pPr marL="0" indent="0">
               <a:buNone/>
             </a:pPr>
             <a:r>
@@ -7341,7 +7359,7 @@
             <a:endParaRPr lang="en-US" sz="1000" dirty="0"/>
           </a:p>
           <a:p>
-            <a:pPr indent="0" marL="0">
+            <a:pPr marL="0" indent="0">
               <a:buNone/>
             </a:pPr>
             <a:r>
@@ -7380,7 +7398,7 @@
           <a:bodyPr wrap="square" rtlCol="0" anchor="ctr"/>
           <a:lstStyle/>
           <a:p>
-            <a:pPr indent="0" marL="0">
+            <a:pPr marL="0" indent="0">
               <a:buNone/>
             </a:pPr>
             <a:r>
@@ -7419,7 +7437,7 @@
           <a:bodyPr wrap="square" rtlCol="0" anchor="ctr"/>
           <a:lstStyle/>
           <a:p>
-            <a:pPr algn="ctr" indent="0" marL="0">
+            <a:pPr marL="0" indent="0" algn="ctr">
               <a:buNone/>
             </a:pPr>
             <a:r>
@@ -7456,6 +7474,13 @@
           </a:solidFill>
           <a:ln/>
         </p:spPr>
+        <p:txBody>
+          <a:bodyPr/>
+          <a:lstStyle/>
+          <a:p>
+            <a:endParaRPr lang="en-US"/>
+          </a:p>
+        </p:txBody>
       </p:sp>
       <p:sp>
         <p:nvSpPr>
@@ -7478,7 +7503,7 @@
           <a:bodyPr wrap="square" rtlCol="0" anchor="ctr"/>
           <a:lstStyle/>
           <a:p>
-            <a:pPr indent="0" marL="0">
+            <a:pPr marL="0" indent="0">
               <a:buNone/>
             </a:pPr>
             <a:r>
@@ -7495,7 +7520,7 @@
             <a:endParaRPr lang="en-US" sz="1000" dirty="0"/>
           </a:p>
           <a:p>
-            <a:pPr indent="0" marL="0">
+            <a:pPr marL="0" indent="0">
               <a:buNone/>
             </a:pPr>
             <a:r>
@@ -7534,7 +7559,7 @@
           <a:bodyPr wrap="square" rtlCol="0" anchor="ctr"/>
           <a:lstStyle/>
           <a:p>
-            <a:pPr indent="0" marL="0">
+            <a:pPr marL="0" indent="0">
               <a:buNone/>
             </a:pPr>
             <a:r>
@@ -7573,7 +7598,7 @@
           <a:bodyPr wrap="square" rtlCol="0" anchor="ctr"/>
           <a:lstStyle/>
           <a:p>
-            <a:pPr algn="ctr" indent="0" marL="0">
+            <a:pPr marL="0" indent="0" algn="ctr">
               <a:buNone/>
             </a:pPr>
             <a:r>
@@ -7610,6 +7635,13 @@
           </a:solidFill>
           <a:ln/>
         </p:spPr>
+        <p:txBody>
+          <a:bodyPr/>
+          <a:lstStyle/>
+          <a:p>
+            <a:endParaRPr lang="en-US"/>
+          </a:p>
+        </p:txBody>
       </p:sp>
       <p:sp>
         <p:nvSpPr>
@@ -7632,7 +7664,7 @@
           <a:bodyPr wrap="square" rtlCol="0" anchor="ctr"/>
           <a:lstStyle/>
           <a:p>
-            <a:pPr indent="0" marL="0">
+            <a:pPr marL="0" indent="0">
               <a:buNone/>
             </a:pPr>
             <a:r>
@@ -7649,7 +7681,7 @@
             <a:endParaRPr lang="en-US" sz="1000" dirty="0"/>
           </a:p>
           <a:p>
-            <a:pPr indent="0" marL="0">
+            <a:pPr marL="0" indent="0">
               <a:buNone/>
             </a:pPr>
             <a:r>
@@ -7688,7 +7720,7 @@
           <a:bodyPr wrap="square" rtlCol="0" anchor="ctr"/>
           <a:lstStyle/>
           <a:p>
-            <a:pPr indent="0" marL="0">
+            <a:pPr marL="0" indent="0">
               <a:buNone/>
             </a:pPr>
             <a:r>
@@ -7727,7 +7759,7 @@
           <a:bodyPr wrap="square" rtlCol="0" anchor="ctr"/>
           <a:lstStyle/>
           <a:p>
-            <a:pPr algn="ctr" indent="0" marL="0">
+            <a:pPr marL="0" indent="0" algn="ctr">
               <a:buNone/>
             </a:pPr>
             <a:r>
@@ -7764,6 +7796,13 @@
           </a:solidFill>
           <a:ln/>
         </p:spPr>
+        <p:txBody>
+          <a:bodyPr/>
+          <a:lstStyle/>
+          <a:p>
+            <a:endParaRPr lang="en-US"/>
+          </a:p>
+        </p:txBody>
       </p:sp>
       <p:sp>
         <p:nvSpPr>
@@ -7786,7 +7825,7 @@
           <a:bodyPr wrap="square" rtlCol="0" anchor="ctr"/>
           <a:lstStyle/>
           <a:p>
-            <a:pPr indent="0" marL="0">
+            <a:pPr marL="0" indent="0">
               <a:buNone/>
             </a:pPr>
             <a:r>
@@ -7803,7 +7842,7 @@
             <a:endParaRPr lang="en-US" sz="1000" dirty="0"/>
           </a:p>
           <a:p>
-            <a:pPr indent="0" marL="0">
+            <a:pPr marL="0" indent="0">
               <a:buNone/>
             </a:pPr>
             <a:r>
@@ -7842,7 +7881,7 @@
           <a:bodyPr wrap="square" rtlCol="0" anchor="ctr"/>
           <a:lstStyle/>
           <a:p>
-            <a:pPr indent="0" marL="0">
+            <a:pPr marL="0" indent="0">
               <a:buNone/>
             </a:pPr>
             <a:r>
@@ -7881,7 +7920,7 @@
           <a:bodyPr wrap="square" rtlCol="0" anchor="ctr"/>
           <a:lstStyle/>
           <a:p>
-            <a:pPr algn="ctr" indent="0" marL="0">
+            <a:pPr marL="0" indent="0" algn="ctr">
               <a:buNone/>
             </a:pPr>
             <a:r>
@@ -7920,7 +7959,7 @@
           <a:bodyPr wrap="square" rtlCol="0" anchor="ctr"/>
           <a:lstStyle/>
           <a:p>
-            <a:pPr indent="0" marL="0">
+            <a:pPr marL="0" indent="0">
               <a:buNone/>
             </a:pPr>
             <a:r>
@@ -7937,7 +7976,7 @@
             <a:endParaRPr lang="en-US" sz="1100" dirty="0"/>
           </a:p>
           <a:p>
-            <a:pPr indent="0" marL="0">
+            <a:pPr marL="0" indent="0">
               <a:buNone/>
             </a:pPr>
             <a:r>
@@ -7976,7 +8015,7 @@
           <a:bodyPr wrap="square" rtlCol="0" anchor="ctr"/>
           <a:lstStyle/>
           <a:p>
-            <a:pPr indent="0" marL="0">
+            <a:pPr marL="0" indent="0">
               <a:buNone/>
             </a:pPr>
             <a:r>
@@ -8010,6 +8049,7 @@
         <a:solidFill>
           <a:srgbClr val="F5F0E8"/>
         </a:solidFill>
+        <a:effectLst/>
       </p:bgPr>
     </p:bg>
     <p:spTree>
@@ -8045,6 +8085,13 @@
           </a:solidFill>
           <a:ln/>
         </p:spPr>
+        <p:txBody>
+          <a:bodyPr/>
+          <a:lstStyle/>
+          <a:p>
+            <a:endParaRPr lang="en-US"/>
+          </a:p>
+        </p:txBody>
       </p:sp>
       <p:sp>
         <p:nvSpPr>
@@ -8067,7 +8114,7 @@
           <a:bodyPr wrap="square" rtlCol="0" anchor="ctr"/>
           <a:lstStyle/>
           <a:p>
-            <a:pPr indent="0" marL="0">
+            <a:pPr marL="0" indent="0">
               <a:buNone/>
             </a:pPr>
             <a:r>
@@ -8106,7 +8153,7 @@
           <a:bodyPr wrap="square" rtlCol="0" anchor="ctr"/>
           <a:lstStyle/>
           <a:p>
-            <a:pPr indent="0" marL="0">
+            <a:pPr marL="0" indent="0">
               <a:buNone/>
             </a:pPr>
             <a:r>
@@ -8145,7 +8192,7 @@
           <a:bodyPr wrap="square" rtlCol="0" anchor="ctr"/>
           <a:lstStyle/>
           <a:p>
-            <a:pPr indent="0" marL="0">
+            <a:pPr marL="0" indent="0">
               <a:buNone/>
             </a:pPr>
             <a:r>
@@ -8182,6 +8229,13 @@
           </a:solidFill>
           <a:ln/>
         </p:spPr>
+        <p:txBody>
+          <a:bodyPr/>
+          <a:lstStyle/>
+          <a:p>
+            <a:endParaRPr lang="en-US"/>
+          </a:p>
+        </p:txBody>
       </p:sp>
       <p:sp>
         <p:nvSpPr>
@@ -8204,7 +8258,7 @@
           <a:bodyPr wrap="square" rtlCol="0" anchor="ctr"/>
           <a:lstStyle/>
           <a:p>
-            <a:pPr indent="0" marL="0">
+            <a:pPr marL="0" indent="0">
               <a:buNone/>
             </a:pPr>
             <a:r>
@@ -8243,7 +8297,7 @@
           <a:bodyPr wrap="square" rtlCol="0" anchor="t"/>
           <a:lstStyle/>
           <a:p>
-            <a:pPr indent="0" marL="0">
+            <a:pPr marL="0" indent="0">
               <a:buNone/>
             </a:pPr>
             <a:r>
@@ -8280,6 +8334,13 @@
           </a:solidFill>
           <a:ln/>
         </p:spPr>
+        <p:txBody>
+          <a:bodyPr/>
+          <a:lstStyle/>
+          <a:p>
+            <a:endParaRPr lang="en-US"/>
+          </a:p>
+        </p:txBody>
       </p:sp>
       <p:sp>
         <p:nvSpPr>
@@ -8302,7 +8363,7 @@
           <a:bodyPr wrap="square" rtlCol="0" anchor="ctr"/>
           <a:lstStyle/>
           <a:p>
-            <a:pPr indent="0" marL="0">
+            <a:pPr marL="0" indent="0">
               <a:buNone/>
             </a:pPr>
             <a:r>
@@ -8341,7 +8402,7 @@
           <a:bodyPr wrap="square" rtlCol="0" anchor="t"/>
           <a:lstStyle/>
           <a:p>
-            <a:pPr indent="0" marL="0">
+            <a:pPr marL="0" indent="0">
               <a:buNone/>
             </a:pPr>
             <a:r>
@@ -8378,6 +8439,13 @@
           </a:solidFill>
           <a:ln/>
         </p:spPr>
+        <p:txBody>
+          <a:bodyPr/>
+          <a:lstStyle/>
+          <a:p>
+            <a:endParaRPr lang="en-US"/>
+          </a:p>
+        </p:txBody>
       </p:sp>
       <p:sp>
         <p:nvSpPr>
@@ -8400,7 +8468,7 @@
           <a:bodyPr wrap="square" rtlCol="0" anchor="ctr"/>
           <a:lstStyle/>
           <a:p>
-            <a:pPr indent="0" marL="0">
+            <a:pPr marL="0" indent="0">
               <a:buNone/>
             </a:pPr>
             <a:r>
@@ -8439,7 +8507,7 @@
           <a:bodyPr wrap="square" rtlCol="0" anchor="t"/>
           <a:lstStyle/>
           <a:p>
-            <a:pPr indent="0" marL="0">
+            <a:pPr marL="0" indent="0">
               <a:buNone/>
             </a:pPr>
             <a:r>
@@ -8476,6 +8544,13 @@
           </a:solidFill>
           <a:ln/>
         </p:spPr>
+        <p:txBody>
+          <a:bodyPr/>
+          <a:lstStyle/>
+          <a:p>
+            <a:endParaRPr lang="en-US"/>
+          </a:p>
+        </p:txBody>
       </p:sp>
       <p:sp>
         <p:nvSpPr>
@@ -8498,7 +8573,7 @@
           <a:bodyPr wrap="square" rtlCol="0" anchor="ctr"/>
           <a:lstStyle/>
           <a:p>
-            <a:pPr indent="0" marL="0">
+            <a:pPr marL="0" indent="0">
               <a:buNone/>
             </a:pPr>
             <a:r>
@@ -8537,7 +8612,7 @@
           <a:bodyPr wrap="square" rtlCol="0" anchor="t"/>
           <a:lstStyle/>
           <a:p>
-            <a:pPr indent="0" marL="0">
+            <a:pPr marL="0" indent="0">
               <a:buNone/>
             </a:pPr>
             <a:r>
@@ -8576,7 +8651,7 @@
           <a:bodyPr wrap="square" rtlCol="0" anchor="ctr"/>
           <a:lstStyle/>
           <a:p>
-            <a:pPr indent="0" marL="0">
+            <a:pPr marL="0" indent="0">
               <a:buNone/>
             </a:pPr>
             <a:r>
@@ -8615,7 +8690,7 @@
           <a:bodyPr wrap="square" rtlCol="0" anchor="ctr"/>
           <a:lstStyle/>
           <a:p>
-            <a:pPr indent="0" marL="0">
+            <a:pPr marL="0" indent="0">
               <a:buNone/>
             </a:pPr>
             <a:r>
@@ -8934,4 +9009,319 @@
     </a:ext>
   </a:extLst>
 </a:theme>
+</file>
+
+<file path=ppt/theme/theme2.xml><?xml version="1.0" encoding="utf-8"?>
+<a:theme xmlns:a="http://schemas.openxmlformats.org/drawingml/2006/main" name="Office Theme">
+  <a:themeElements>
+    <a:clrScheme name="Office">
+      <a:dk1>
+        <a:sysClr val="windowText" lastClr="000000"/>
+      </a:dk1>
+      <a:lt1>
+        <a:sysClr val="window" lastClr="FFFFFF"/>
+      </a:lt1>
+      <a:dk2>
+        <a:srgbClr val="0E2841"/>
+      </a:dk2>
+      <a:lt2>
+        <a:srgbClr val="E8E8E8"/>
+      </a:lt2>
+      <a:accent1>
+        <a:srgbClr val="156082"/>
+      </a:accent1>
+      <a:accent2>
+        <a:srgbClr val="E97132"/>
+      </a:accent2>
+      <a:accent3>
+        <a:srgbClr val="196B24"/>
+      </a:accent3>
+      <a:accent4>
+        <a:srgbClr val="0F9ED5"/>
+      </a:accent4>
+      <a:accent5>
+        <a:srgbClr val="A02B93"/>
+      </a:accent5>
+      <a:accent6>
+        <a:srgbClr val="4EA72E"/>
+      </a:accent6>
+      <a:hlink>
+        <a:srgbClr val="467886"/>
+      </a:hlink>
+      <a:folHlink>
+        <a:srgbClr val="96607D"/>
+      </a:folHlink>
+    </a:clrScheme>
+    <a:fontScheme name="Office">
+      <a:majorFont>
+        <a:latin typeface="Aptos Display" panose="02110004020202020204"/>
+        <a:ea typeface=""/>
+        <a:cs typeface=""/>
+        <a:font script="Jpan" typeface="游ゴシック Light"/>
+        <a:font script="Hang" typeface="맑은 고딕"/>
+        <a:font script="Hans" typeface="等线 Light"/>
+        <a:font script="Hant" typeface="新細明體"/>
+        <a:font script="Arab" typeface="Times New Roman"/>
+        <a:font script="Hebr" typeface="Times New Roman"/>
+        <a:font script="Thai" typeface="Angsana New"/>
+        <a:font script="Ethi" typeface="Nyala"/>
+        <a:font script="Beng" typeface="Vrinda"/>
+        <a:font script="Gujr" typeface="Shruti"/>
+        <a:font script="Khmr" typeface="MoolBoran"/>
+        <a:font script="Knda" typeface="Tunga"/>
+        <a:font script="Guru" typeface="Raavi"/>
+        <a:font script="Cans" typeface="Euphemia"/>
+        <a:font script="Cher" typeface="Plantagenet Cherokee"/>
+        <a:font script="Yiii" typeface="Microsoft Yi Baiti"/>
+        <a:font script="Tibt" typeface="Microsoft Himalaya"/>
+        <a:font script="Thaa" typeface="MV Boli"/>
+        <a:font script="Deva" typeface="Mangal"/>
+        <a:font script="Telu" typeface="Gautami"/>
+        <a:font script="Taml" typeface="Latha"/>
+        <a:font script="Syrc" typeface="Estrangelo Edessa"/>
+        <a:font script="Orya" typeface="Kalinga"/>
+        <a:font script="Mlym" typeface="Kartika"/>
+        <a:font script="Laoo" typeface="DokChampa"/>
+        <a:font script="Sinh" typeface="Iskoola Pota"/>
+        <a:font script="Mong" typeface="Mongolian Baiti"/>
+        <a:font script="Viet" typeface="Times New Roman"/>
+        <a:font script="Uigh" typeface="Microsoft Uighur"/>
+        <a:font script="Geor" typeface="Sylfaen"/>
+        <a:font script="Armn" typeface="Arial"/>
+        <a:font script="Bugi" typeface="Leelawadee UI"/>
+        <a:font script="Bopo" typeface="Microsoft JhengHei"/>
+        <a:font script="Java" typeface="Javanese Text"/>
+        <a:font script="Lisu" typeface="Segoe UI"/>
+        <a:font script="Mymr" typeface="Myanmar Text"/>
+        <a:font script="Nkoo" typeface="Ebrima"/>
+        <a:font script="Olck" typeface="Nirmala UI"/>
+        <a:font script="Osma" typeface="Ebrima"/>
+        <a:font script="Phag" typeface="Phagspa"/>
+        <a:font script="Syrn" typeface="Estrangelo Edessa"/>
+        <a:font script="Syrj" typeface="Estrangelo Edessa"/>
+        <a:font script="Syre" typeface="Estrangelo Edessa"/>
+        <a:font script="Sora" typeface="Nirmala UI"/>
+        <a:font script="Tale" typeface="Microsoft Tai Le"/>
+        <a:font script="Talu" typeface="Microsoft New Tai Lue"/>
+        <a:font script="Tfng" typeface="Ebrima"/>
+      </a:majorFont>
+      <a:minorFont>
+        <a:latin typeface="Aptos" panose="02110004020202020204"/>
+        <a:ea typeface=""/>
+        <a:cs typeface=""/>
+        <a:font script="Jpan" typeface="游ゴシック"/>
+        <a:font script="Hang" typeface="맑은 고딕"/>
+        <a:font script="Hans" typeface="等线"/>
+        <a:font script="Hant" typeface="新細明體"/>
+        <a:font script="Arab" typeface="Arial"/>
+        <a:font script="Hebr" typeface="Arial"/>
+        <a:font script="Thai" typeface="Cordia New"/>
+        <a:font script="Ethi" typeface="Nyala"/>
+        <a:font script="Beng" typeface="Vrinda"/>
+        <a:font script="Gujr" typeface="Shruti"/>
+        <a:font script="Khmr" typeface="DaunPenh"/>
+        <a:font script="Knda" typeface="Tunga"/>
+        <a:font script="Guru" typeface="Raavi"/>
+        <a:font script="Cans" typeface="Euphemia"/>
+        <a:font script="Cher" typeface="Plantagenet Cherokee"/>
+        <a:font script="Yiii" typeface="Microsoft Yi Baiti"/>
+        <a:font script="Tibt" typeface="Microsoft Himalaya"/>
+        <a:font script="Thaa" typeface="MV Boli"/>
+        <a:font script="Deva" typeface="Mangal"/>
+        <a:font script="Telu" typeface="Gautami"/>
+        <a:font script="Taml" typeface="Latha"/>
+        <a:font script="Syrc" typeface="Estrangelo Edessa"/>
+        <a:font script="Orya" typeface="Kalinga"/>
+        <a:font script="Mlym" typeface="Kartika"/>
+        <a:font script="Laoo" typeface="DokChampa"/>
+        <a:font script="Sinh" typeface="Iskoola Pota"/>
+        <a:font script="Mong" typeface="Mongolian Baiti"/>
+        <a:font script="Viet" typeface="Arial"/>
+        <a:font script="Uigh" typeface="Microsoft Uighur"/>
+        <a:font script="Geor" typeface="Sylfaen"/>
+        <a:font script="Armn" typeface="Arial"/>
+        <a:font script="Bugi" typeface="Leelawadee UI"/>
+        <a:font script="Bopo" typeface="Microsoft JhengHei"/>
+        <a:font script="Java" typeface="Javanese Text"/>
+        <a:font script="Lisu" typeface="Segoe UI"/>
+        <a:font script="Mymr" typeface="Myanmar Text"/>
+        <a:font script="Nkoo" typeface="Ebrima"/>
+        <a:font script="Olck" typeface="Nirmala UI"/>
+        <a:font script="Osma" typeface="Ebrima"/>
+        <a:font script="Phag" typeface="Phagspa"/>
+        <a:font script="Syrn" typeface="Estrangelo Edessa"/>
+        <a:font script="Syrj" typeface="Estrangelo Edessa"/>
+        <a:font script="Syre" typeface="Estrangelo Edessa"/>
+        <a:font script="Sora" typeface="Nirmala UI"/>
+        <a:font script="Tale" typeface="Microsoft Tai Le"/>
+        <a:font script="Talu" typeface="Microsoft New Tai Lue"/>
+        <a:font script="Tfng" typeface="Ebrima"/>
+      </a:minorFont>
+    </a:fontScheme>
+    <a:fmtScheme name="Office">
+      <a:fillStyleLst>
+        <a:solidFill>
+          <a:schemeClr val="phClr"/>
+        </a:solidFill>
+        <a:gradFill rotWithShape="1">
+          <a:gsLst>
+            <a:gs pos="0">
+              <a:schemeClr val="phClr">
+                <a:lumMod val="110000"/>
+                <a:satMod val="105000"/>
+                <a:tint val="67000"/>
+              </a:schemeClr>
+            </a:gs>
+            <a:gs pos="50000">
+              <a:schemeClr val="phClr">
+                <a:lumMod val="105000"/>
+                <a:satMod val="103000"/>
+                <a:tint val="73000"/>
+              </a:schemeClr>
+            </a:gs>
+            <a:gs pos="100000">
+              <a:schemeClr val="phClr">
+                <a:lumMod val="105000"/>
+                <a:satMod val="109000"/>
+                <a:tint val="81000"/>
+              </a:schemeClr>
+            </a:gs>
+          </a:gsLst>
+          <a:lin ang="5400000" scaled="0"/>
+        </a:gradFill>
+        <a:gradFill rotWithShape="1">
+          <a:gsLst>
+            <a:gs pos="0">
+              <a:schemeClr val="phClr">
+                <a:satMod val="103000"/>
+                <a:lumMod val="102000"/>
+                <a:tint val="94000"/>
+              </a:schemeClr>
+            </a:gs>
+            <a:gs pos="50000">
+              <a:schemeClr val="phClr">
+                <a:satMod val="110000"/>
+                <a:lumMod val="100000"/>
+                <a:shade val="100000"/>
+              </a:schemeClr>
+            </a:gs>
+            <a:gs pos="100000">
+              <a:schemeClr val="phClr">
+                <a:lumMod val="99000"/>
+                <a:satMod val="120000"/>
+                <a:shade val="78000"/>
+              </a:schemeClr>
+            </a:gs>
+          </a:gsLst>
+          <a:lin ang="5400000" scaled="0"/>
+        </a:gradFill>
+      </a:fillStyleLst>
+      <a:lnStyleLst>
+        <a:ln w="12700" cap="flat" cmpd="sng" algn="ctr">
+          <a:solidFill>
+            <a:schemeClr val="phClr"/>
+          </a:solidFill>
+          <a:prstDash val="solid"/>
+          <a:miter lim="800000"/>
+        </a:ln>
+        <a:ln w="19050" cap="flat" cmpd="sng" algn="ctr">
+          <a:solidFill>
+            <a:schemeClr val="phClr"/>
+          </a:solidFill>
+          <a:prstDash val="solid"/>
+          <a:miter lim="800000"/>
+        </a:ln>
+        <a:ln w="25400" cap="flat" cmpd="sng" algn="ctr">
+          <a:solidFill>
+            <a:schemeClr val="phClr"/>
+          </a:solidFill>
+          <a:prstDash val="solid"/>
+          <a:miter lim="800000"/>
+        </a:ln>
+      </a:lnStyleLst>
+      <a:effectStyleLst>
+        <a:effectStyle>
+          <a:effectLst/>
+        </a:effectStyle>
+        <a:effectStyle>
+          <a:effectLst/>
+        </a:effectStyle>
+        <a:effectStyle>
+          <a:effectLst>
+            <a:outerShdw blurRad="57150" dist="19050" dir="5400000" algn="ctr" rotWithShape="0">
+              <a:srgbClr val="000000">
+                <a:alpha val="63000"/>
+              </a:srgbClr>
+            </a:outerShdw>
+          </a:effectLst>
+        </a:effectStyle>
+      </a:effectStyleLst>
+      <a:bgFillStyleLst>
+        <a:solidFill>
+          <a:schemeClr val="phClr"/>
+        </a:solidFill>
+        <a:solidFill>
+          <a:schemeClr val="phClr">
+            <a:tint val="95000"/>
+            <a:satMod val="170000"/>
+          </a:schemeClr>
+        </a:solidFill>
+        <a:gradFill rotWithShape="1">
+          <a:gsLst>
+            <a:gs pos="0">
+              <a:schemeClr val="phClr">
+                <a:tint val="93000"/>
+                <a:satMod val="150000"/>
+                <a:shade val="98000"/>
+                <a:lumMod val="102000"/>
+              </a:schemeClr>
+            </a:gs>
+            <a:gs pos="50000">
+              <a:schemeClr val="phClr">
+                <a:tint val="98000"/>
+                <a:satMod val="130000"/>
+                <a:shade val="90000"/>
+                <a:lumMod val="103000"/>
+              </a:schemeClr>
+            </a:gs>
+            <a:gs pos="100000">
+              <a:schemeClr val="phClr">
+                <a:shade val="63000"/>
+                <a:satMod val="120000"/>
+              </a:schemeClr>
+            </a:gs>
+          </a:gsLst>
+          <a:lin ang="5400000" scaled="0"/>
+        </a:gradFill>
+      </a:bgFillStyleLst>
+    </a:fmtScheme>
+  </a:themeElements>
+  <a:objectDefaults>
+    <a:lnDef>
+      <a:spPr/>
+      <a:bodyPr/>
+      <a:lstStyle/>
+      <a:style>
+        <a:lnRef idx="2">
+          <a:schemeClr val="accent1"/>
+        </a:lnRef>
+        <a:fillRef idx="0">
+          <a:schemeClr val="accent1"/>
+        </a:fillRef>
+        <a:effectRef idx="1">
+          <a:schemeClr val="accent1"/>
+        </a:effectRef>
+        <a:fontRef idx="minor">
+          <a:schemeClr val="tx1"/>
+        </a:fontRef>
+      </a:style>
+    </a:lnDef>
+  </a:objectDefaults>
+  <a:extraClrSchemeLst/>
+  <a:extLst>
+    <a:ext uri="{05A4C25C-085E-4340-85A3-A5531E510DB2}">
+      <thm15:themeFamily xmlns:thm15="http://schemas.microsoft.com/office/thememl/2012/main" name="Office Theme" id="{2E142A2C-CD16-42D6-873A-C26D2A0506FA}" vid="{1BDDFF52-6CD6-40A5-AB3C-68EB2F1E4D0A}"/>
+    </a:ext>
+  </a:extLst>
+</a:theme>
 </file>
</xml_diff>